<commit_message>
pdf generation bug initial fix
</commit_message>
<xml_diff>
--- a/examples/test.pptx
+++ b/examples/test.pptx
@@ -17,6 +17,25 @@
     <p:sldId id="265" r:id="rId11"/>
     <p:sldId id="266" r:id="rId12"/>
     <p:sldId id="267" r:id="rId13"/>
+    <p:sldId id="268" r:id="rId14"/>
+    <p:sldId id="269" r:id="rId15"/>
+    <p:sldId id="270" r:id="rId16"/>
+    <p:sldId id="271" r:id="rId17"/>
+    <p:sldId id="272" r:id="rId18"/>
+    <p:sldId id="273" r:id="rId19"/>
+    <p:sldId id="274" r:id="rId20"/>
+    <p:sldId id="275" r:id="rId21"/>
+    <p:sldId id="276" r:id="rId22"/>
+    <p:sldId id="277" r:id="rId23"/>
+    <p:sldId id="278" r:id="rId24"/>
+    <p:sldId id="279" r:id="rId25"/>
+    <p:sldId id="280" r:id="rId26"/>
+    <p:sldId id="281" r:id="rId27"/>
+    <p:sldId id="282" r:id="rId28"/>
+    <p:sldId id="283" r:id="rId29"/>
+    <p:sldId id="284" r:id="rId30"/>
+    <p:sldId id="285" r:id="rId31"/>
+    <p:sldId id="286" r:id="rId32"/>
   </p:sldIdLst>
   <p:sldSz cx="9144000" cy="5143500" type="screen16x9"/>
   <p:notesSz cx="6858000" cy="9144000"/>
@@ -3121,14 +3140,14 @@
             </a:pPr>
             <a:r>
               <a:rPr/>
-              <a:t>A Vertical Bar chart</a:t>
+              <a:t>A Custom Chart called Happy chart</a:t>
             </a:r>
           </a:p>
         </p:txBody>
       </p:sp>
       <p:pic>
         <p:nvPicPr>
-          <p:cNvPr descr="/var/folders/bp/w4c2kztn5fg7yk8vg8k_2wgc0000gn/T/doodlcat3f6my/svg/barchart_0.png" id="0" name="Picture 1"/>
+          <p:cNvPr descr="/var/folders/bp/w4c2kztn5fg7yk8vg8k_2wgc0000gn/T/doodlngwzbyw2/svg/happy_0.png" id="0" name="Picture 1"/>
           <p:cNvPicPr>
             <a:picLocks noGrp="1" noChangeAspect="1"/>
           </p:cNvPicPr>
@@ -3183,17 +3202,16 @@
             </a:pPr>
             <a:r>
               <a:rPr/>
-              <a:t>&lt;barchart
+              <a:t>&lt;happy
 data='[
   { "label": "Apples", "value": 10 },
   { "label": "Bananas", "value": 20 },
   { "label": "Cherries", "value": 15 },
   { "label": "Grapes", "value": 25 }
 ]'
-  size='{"width":500,"height":500}'
-  colors='["#FF6700","#008000"]'
-  horizontal='true'
-  moving_average='true'
+  width=500
+  height=500
+  colors='pastel'
 &gt;</a:t>
             </a:r>
           </a:p>
@@ -3241,14 +3259,14 @@
             </a:pPr>
             <a:r>
               <a:rPr/>
-              <a:t>A vertical tree chart</a:t>
+              <a:t>A VERTICAL stacked areachart</a:t>
             </a:r>
           </a:p>
         </p:txBody>
       </p:sp>
       <p:pic>
         <p:nvPicPr>
-          <p:cNvPr descr="/var/folders/bp/w4c2kztn5fg7yk8vg8k_2wgc0000gn/T/doodlcat3f6my/svg/tree_0.png" id="0" name="Picture 1"/>
+          <p:cNvPr descr="/var/folders/bp/w4c2kztn5fg7yk8vg8k_2wgc0000gn/T/doodlngwzbyw2/svg/stacked_areachart_1.png" id="0" name="Picture 1"/>
           <p:cNvPicPr>
             <a:picLocks noGrp="1" noChangeAspect="1"/>
           </p:cNvPicPr>
@@ -3262,8 +3280,8 @@
         </p:blipFill>
         <p:spPr bwMode="auto">
           <a:xfrm>
-            <a:off x="1790700" y="1193800"/>
-            <a:ext cx="5549900" cy="2882900"/>
+            <a:off x="2844800" y="1193800"/>
+            <a:ext cx="3454400" cy="2882900"/>
           </a:xfrm>
           <a:prstGeom prst="rect">
             <a:avLst/>
@@ -3303,24 +3321,14 @@
             </a:pPr>
             <a:r>
               <a:rPr/>
-              <a:t>&lt;tree
-    data='{
-    "name": "root",
-    "children": [
-            { "name": "A", "value": 10 },
-            { "name": "B", "value": 20 },
-            { "name": "C", "children": [
-                { "name": "C1", "value": 10 },
-                { "name": "C2", "value": 5 },
-                { "name": "C3", "value": 15 }
-            ]},
-            { "name": "D", "value": 40 }
-        ]
-    }
-    '
-    size='{"width":1000,"height":500}'
-    colors='deep'
-    vertical=True&gt;</a:t>
+              <a:t>&lt;stacked_areachart
+  path= "data/label_category_value.json"
+  width=1200
+  height=1000
+  colors='deep'
+  x_label_angle=90
+  show_legend='true'
+&gt;</a:t>
             </a:r>
           </a:p>
         </p:txBody>
@@ -3367,14 +3375,14 @@
             </a:pPr>
             <a:r>
               <a:rPr/>
-              <a:t>A gantt chart</a:t>
+              <a:t>A bollinger band diagram</a:t>
             </a:r>
           </a:p>
         </p:txBody>
       </p:sp>
       <p:pic>
         <p:nvPicPr>
-          <p:cNvPr descr="/var/folders/bp/w4c2kztn5fg7yk8vg8k_2wgc0000gn/T/doodlcat3f6my/svg/gantt_0.png" id="0" name="Picture 1"/>
+          <p:cNvPr descr="/var/folders/bp/w4c2kztn5fg7yk8vg8k_2wgc0000gn/T/doodlngwzbyw2/svg/bollinger_0.png" id="0" name="Picture 1"/>
           <p:cNvPicPr>
             <a:picLocks noGrp="1" noChangeAspect="1"/>
           </p:cNvPicPr>
@@ -3388,8 +3396,8 @@
         </p:blipFill>
         <p:spPr bwMode="auto">
           <a:xfrm>
-            <a:off x="1689100" y="1193800"/>
-            <a:ext cx="5765800" cy="2882900"/>
+            <a:off x="3124200" y="1193800"/>
+            <a:ext cx="2882900" cy="2882900"/>
           </a:xfrm>
           <a:prstGeom prst="rect">
             <a:avLst/>
@@ -3429,16 +3437,10 @@
             </a:pPr>
             <a:r>
               <a:rPr/>
-              <a:t>&lt;gantt
-  data='[
-    { "task": "Planning", "start": "2024-03-01", "end": "2024-03-05" },
-    { "task": "Design", "start": "2024-03-06", "end": "2024-03-12" },
-    { "task": "Development", "start": "2024-03-13", "end": "2024-03-25" },
-    { "task": "Testing", "start": "2024-03-26", "end": "2024-03-30" },
-    { "task": "Deployment", "start": "2024-03-31", "end": "2024-04-02" }
-  ]'
-  size='{"width":1000,"height":500}'
-  colors='deep'
+              <a:t>&lt;bollinger
+path= "data/bollinger_50.json"
+  size='{"width":1000,"height":1000}'
+  colors='pastel'
 &gt;</a:t>
             </a:r>
           </a:p>
@@ -3486,14 +3488,14 @@
             </a:pPr>
             <a:r>
               <a:rPr/>
-              <a:t>A chord diagram</a:t>
+              <a:t>An curved areachart</a:t>
             </a:r>
           </a:p>
         </p:txBody>
       </p:sp>
       <p:pic>
         <p:nvPicPr>
-          <p:cNvPr descr="/var/folders/bp/w4c2kztn5fg7yk8vg8k_2wgc0000gn/T/doodlcat3f6my/svg/chord_0.png" id="0" name="Picture 1"/>
+          <p:cNvPr descr="/var/folders/bp/w4c2kztn5fg7yk8vg8k_2wgc0000gn/T/doodlngwzbyw2/svg/areachart_0.png" id="0" name="Picture 1"/>
           <p:cNvPicPr>
             <a:picLocks noGrp="1" noChangeAspect="1"/>
           </p:cNvPicPr>
@@ -3548,16 +3550,841 @@
             </a:pPr>
             <a:r>
               <a:rPr/>
-              <a:t>&lt;chord
+              <a:t>&lt;areachart
 data='[
-  [0, 5, 10, 2],
-  [5, 0, 3, 7],
-  [10, 3, 0, 6],
-  [2, 7, 6, 0]
-]
+  { "x": 1, "y": 10 }, 
+  { "x": 2, "y": 20 },
+  { "x": 3, "y": 15 },
+  { "x": 4, "y": 25 },
+  { "x": 5, "y": 30 },
+  { "x": 6, "y": 35 }
+  ]'
+  width=500
+  height=500
+  colors='deep'
+  curved='true'
+&gt;</a:t>
+            </a:r>
+          </a:p>
+        </p:txBody>
+      </p:sp>
+    </p:spTree>
+  </p:cSld>
+</p:sld>
+</file>
+
+<file path=ppt/slides/slide13.xml><?xml version="1.0" encoding="utf-8"?>
+<p:sld xmlns:a="http://schemas.openxmlformats.org/drawingml/2006/main" xmlns:r="http://schemas.openxmlformats.org/officeDocument/2006/relationships" xmlns:p="http://schemas.openxmlformats.org/presentationml/2006/main">
+  <p:cSld>
+    <p:spTree>
+      <p:nvGrpSpPr>
+        <p:cNvPr id="1" name=""/>
+        <p:cNvGrpSpPr/>
+        <p:nvPr/>
+      </p:nvGrpSpPr>
+      <p:grpSpPr>
+        <a:xfrm>
+          <a:off x="0" y="0"/>
+          <a:ext cx="0" cy="0"/>
+          <a:chOff x="0" y="0"/>
+          <a:chExt cx="0" cy="0"/>
+        </a:xfrm>
+      </p:grpSpPr>
+      <p:sp>
+        <p:nvSpPr>
+          <p:cNvPr id="2" name="Title 1"/>
+          <p:cNvSpPr>
+            <a:spLocks noGrp="1"/>
+          </p:cNvSpPr>
+          <p:nvPr>
+            <p:ph type="title"/>
+          </p:nvPr>
+        </p:nvSpPr>
+        <p:spPr/>
+        <p:txBody>
+          <a:bodyPr/>
+          <a:lstStyle/>
+          <a:p>
+            <a:pPr lvl="0" indent="0" marL="0">
+              <a:buNone/>
+            </a:pPr>
+            <a:r>
+              <a:rPr/>
+              <a:t>An non-curved areachart</a:t>
+            </a:r>
+          </a:p>
+        </p:txBody>
+      </p:sp>
+      <p:pic>
+        <p:nvPicPr>
+          <p:cNvPr descr="/var/folders/bp/w4c2kztn5fg7yk8vg8k_2wgc0000gn/T/doodlngwzbyw2/svg/areachart_1.png" id="0" name="Picture 1"/>
+          <p:cNvPicPr>
+            <a:picLocks noGrp="1" noChangeAspect="1"/>
+          </p:cNvPicPr>
+          <p:nvPr/>
+        </p:nvPicPr>
+        <p:blipFill>
+          <a:blip r:embed="rId2"/>
+          <a:stretch>
+            <a:fillRect/>
+          </a:stretch>
+        </p:blipFill>
+        <p:spPr bwMode="auto">
+          <a:xfrm>
+            <a:off x="3124200" y="1193800"/>
+            <a:ext cx="2882900" cy="2882900"/>
+          </a:xfrm>
+          <a:prstGeom prst="rect">
+            <a:avLst/>
+          </a:prstGeom>
+          <a:noFill/>
+          <a:ln w="9525">
+            <a:noFill/>
+            <a:headEnd/>
+            <a:tailEnd/>
+          </a:ln>
+        </p:spPr>
+      </p:pic>
+      <p:sp>
+        <p:nvSpPr>
+          <p:cNvPr id="1" name="TextBox 3"/>
+          <p:cNvSpPr txBox="1"/>
+          <p:nvPr>
+            <p:ph idx="1"/>
+          </p:nvPr>
+        </p:nvSpPr>
+        <p:spPr>
+          <a:xfrm>
+            <a:off x="457200" y="4076700"/>
+            <a:ext cx="8229600" cy="508000"/>
+          </a:xfrm>
+          <a:prstGeom prst="rect">
+            <a:avLst/>
+          </a:prstGeom>
+          <a:noFill/>
+        </p:spPr>
+        <p:txBody>
+          <a:bodyPr/>
+          <a:lstStyle/>
+          <a:p>
+            <a:pPr lvl="0" indent="0" marL="0" algn="ctr">
+              <a:buNone/>
+            </a:pPr>
+            <a:r>
+              <a:rPr/>
+              <a:t>&lt;areachart
+data='[
+  { "x": 1, "y": 10 }, 
+  { "x": 2, "y": 20 },
+  { "x": 3, "y": 15 },
+  { "x": 4, "y": 25 },
+  { "x": 5, "y": 30 },
+  { "x": 6, "y": 35 }
+  ]'
+  width=500
+  height=500
+  colors='deep'
+&gt;</a:t>
+            </a:r>
+          </a:p>
+        </p:txBody>
+      </p:sp>
+    </p:spTree>
+  </p:cSld>
+</p:sld>
+</file>
+
+<file path=ppt/slides/slide14.xml><?xml version="1.0" encoding="utf-8"?>
+<p:sld xmlns:a="http://schemas.openxmlformats.org/drawingml/2006/main" xmlns:r="http://schemas.openxmlformats.org/officeDocument/2006/relationships" xmlns:p="http://schemas.openxmlformats.org/presentationml/2006/main">
+  <p:cSld>
+    <p:spTree>
+      <p:nvGrpSpPr>
+        <p:cNvPr id="1" name=""/>
+        <p:cNvGrpSpPr/>
+        <p:nvPr/>
+      </p:nvGrpSpPr>
+      <p:grpSpPr>
+        <a:xfrm>
+          <a:off x="0" y="0"/>
+          <a:ext cx="0" cy="0"/>
+          <a:chOff x="0" y="0"/>
+          <a:chExt cx="0" cy="0"/>
+        </a:xfrm>
+      </p:grpSpPr>
+      <p:sp>
+        <p:nvSpPr>
+          <p:cNvPr id="2" name="Title 1"/>
+          <p:cNvSpPr>
+            <a:spLocks noGrp="1"/>
+          </p:cNvSpPr>
+          <p:nvPr>
+            <p:ph type="title"/>
+          </p:nvPr>
+        </p:nvSpPr>
+        <p:spPr/>
+        <p:txBody>
+          <a:bodyPr/>
+          <a:lstStyle/>
+          <a:p>
+            <a:pPr lvl="0" indent="0" marL="0">
+              <a:buNone/>
+            </a:pPr>
+            <a:r>
+              <a:rPr/>
+              <a:t>A venn diagram</a:t>
+            </a:r>
+          </a:p>
+        </p:txBody>
+      </p:sp>
+      <p:pic>
+        <p:nvPicPr>
+          <p:cNvPr descr="/var/folders/bp/w4c2kztn5fg7yk8vg8k_2wgc0000gn/T/doodlngwzbyw2/svg/vennchart_0.png" id="0" name="Picture 1"/>
+          <p:cNvPicPr>
+            <a:picLocks noGrp="1" noChangeAspect="1"/>
+          </p:cNvPicPr>
+          <p:nvPr/>
+        </p:nvPicPr>
+        <p:blipFill>
+          <a:blip r:embed="rId2"/>
+          <a:stretch>
+            <a:fillRect/>
+          </a:stretch>
+        </p:blipFill>
+        <p:spPr bwMode="auto">
+          <a:xfrm>
+            <a:off x="3124200" y="1193800"/>
+            <a:ext cx="2882900" cy="2882900"/>
+          </a:xfrm>
+          <a:prstGeom prst="rect">
+            <a:avLst/>
+          </a:prstGeom>
+          <a:noFill/>
+          <a:ln w="9525">
+            <a:noFill/>
+            <a:headEnd/>
+            <a:tailEnd/>
+          </a:ln>
+        </p:spPr>
+      </p:pic>
+      <p:sp>
+        <p:nvSpPr>
+          <p:cNvPr id="1" name="TextBox 3"/>
+          <p:cNvSpPr txBox="1"/>
+          <p:nvPr>
+            <p:ph idx="1"/>
+          </p:nvPr>
+        </p:nvSpPr>
+        <p:spPr>
+          <a:xfrm>
+            <a:off x="457200" y="4076700"/>
+            <a:ext cx="8229600" cy="508000"/>
+          </a:xfrm>
+          <a:prstGeom prst="rect">
+            <a:avLst/>
+          </a:prstGeom>
+          <a:noFill/>
+        </p:spPr>
+        <p:txBody>
+          <a:bodyPr/>
+          <a:lstStyle/>
+          <a:p>
+            <a:pPr lvl="0" indent="0" marL="0" algn="ctr">
+              <a:buNone/>
+            </a:pPr>
+            <a:r>
+              <a:rPr/>
+              <a:t>&lt;vennchart
+data='
+  [ 
+  {"sets": ["A"], "size": 10}, 
+    {"sets": ["B"], "size": 15},
+    {"sets": ["C"], "size": 20},
+    {"sets": ["A","B"], "size": 5},
+    {"sets": ["A","C"], "size": 3},
+    {"sets": ["B","C"], "size": 4},
+    {"sets": ["A","B","C"], "size": 2}
+  ]
 '
   size='{"width":500,"height":500}'
   colors='deep'
+&gt;</a:t>
+            </a:r>
+          </a:p>
+        </p:txBody>
+      </p:sp>
+    </p:spTree>
+  </p:cSld>
+</p:sld>
+</file>
+
+<file path=ppt/slides/slide15.xml><?xml version="1.0" encoding="utf-8"?>
+<p:sld xmlns:a="http://schemas.openxmlformats.org/drawingml/2006/main" xmlns:r="http://schemas.openxmlformats.org/officeDocument/2006/relationships" xmlns:p="http://schemas.openxmlformats.org/presentationml/2006/main">
+  <p:cSld>
+    <p:spTree>
+      <p:nvGrpSpPr>
+        <p:cNvPr id="1" name=""/>
+        <p:cNvGrpSpPr/>
+        <p:nvPr/>
+      </p:nvGrpSpPr>
+      <p:grpSpPr>
+        <a:xfrm>
+          <a:off x="0" y="0"/>
+          <a:ext cx="0" cy="0"/>
+          <a:chOff x="0" y="0"/>
+          <a:chExt cx="0" cy="0"/>
+        </a:xfrm>
+      </p:grpSpPr>
+      <p:sp>
+        <p:nvSpPr>
+          <p:cNvPr id="2" name="Title 1"/>
+          <p:cNvSpPr>
+            <a:spLocks noGrp="1"/>
+          </p:cNvSpPr>
+          <p:nvPr>
+            <p:ph type="title"/>
+          </p:nvPr>
+        </p:nvSpPr>
+        <p:spPr/>
+        <p:txBody>
+          <a:bodyPr/>
+          <a:lstStyle/>
+          <a:p>
+            <a:pPr lvl="0" indent="0" marL="0">
+              <a:buNone/>
+            </a:pPr>
+            <a:r>
+              <a:rPr/>
+              <a:t>A Vertical Bar chart</a:t>
+            </a:r>
+          </a:p>
+        </p:txBody>
+      </p:sp>
+      <p:pic>
+        <p:nvPicPr>
+          <p:cNvPr descr="/var/folders/bp/w4c2kztn5fg7yk8vg8k_2wgc0000gn/T/doodlngwzbyw2/svg/barchart_0.png" id="0" name="Picture 1"/>
+          <p:cNvPicPr>
+            <a:picLocks noGrp="1" noChangeAspect="1"/>
+          </p:cNvPicPr>
+          <p:nvPr/>
+        </p:nvPicPr>
+        <p:blipFill>
+          <a:blip r:embed="rId2"/>
+          <a:stretch>
+            <a:fillRect/>
+          </a:stretch>
+        </p:blipFill>
+        <p:spPr bwMode="auto">
+          <a:xfrm>
+            <a:off x="3124200" y="1193800"/>
+            <a:ext cx="2882900" cy="2882900"/>
+          </a:xfrm>
+          <a:prstGeom prst="rect">
+            <a:avLst/>
+          </a:prstGeom>
+          <a:noFill/>
+          <a:ln w="9525">
+            <a:noFill/>
+            <a:headEnd/>
+            <a:tailEnd/>
+          </a:ln>
+        </p:spPr>
+      </p:pic>
+      <p:sp>
+        <p:nvSpPr>
+          <p:cNvPr id="1" name="TextBox 3"/>
+          <p:cNvSpPr txBox="1"/>
+          <p:nvPr>
+            <p:ph idx="1"/>
+          </p:nvPr>
+        </p:nvSpPr>
+        <p:spPr>
+          <a:xfrm>
+            <a:off x="457200" y="4076700"/>
+            <a:ext cx="8229600" cy="508000"/>
+          </a:xfrm>
+          <a:prstGeom prst="rect">
+            <a:avLst/>
+          </a:prstGeom>
+          <a:noFill/>
+        </p:spPr>
+        <p:txBody>
+          <a:bodyPr/>
+          <a:lstStyle/>
+          <a:p>
+            <a:pPr lvl="0" indent="0" marL="0" algn="ctr">
+              <a:buNone/>
+            </a:pPr>
+            <a:r>
+              <a:rPr/>
+              <a:t>&lt;barchart
+  data='[
+    { "label": "Apples", "value": 10 },
+    { "label": "Bananas", "value": 20 },
+    { "label": "Cherries", "value": 15 },
+    { "label": "Grapes", "value": 25 }
+  ]'
+  width=500
+  height=500
+  colors='["#FF6700","#008000"]'
+  horizontal='true'
+  moving_average='true'
+  x_label_angle=90
+&gt;</a:t>
+            </a:r>
+          </a:p>
+        </p:txBody>
+      </p:sp>
+    </p:spTree>
+  </p:cSld>
+</p:sld>
+</file>
+
+<file path=ppt/slides/slide16.xml><?xml version="1.0" encoding="utf-8"?>
+<p:sld xmlns:a="http://schemas.openxmlformats.org/drawingml/2006/main" xmlns:r="http://schemas.openxmlformats.org/officeDocument/2006/relationships" xmlns:p="http://schemas.openxmlformats.org/presentationml/2006/main">
+  <p:cSld>
+    <p:spTree>
+      <p:nvGrpSpPr>
+        <p:cNvPr id="1" name=""/>
+        <p:cNvGrpSpPr/>
+        <p:nvPr/>
+      </p:nvGrpSpPr>
+      <p:grpSpPr>
+        <a:xfrm>
+          <a:off x="0" y="0"/>
+          <a:ext cx="0" cy="0"/>
+          <a:chOff x="0" y="0"/>
+          <a:chExt cx="0" cy="0"/>
+        </a:xfrm>
+      </p:grpSpPr>
+      <p:sp>
+        <p:nvSpPr>
+          <p:cNvPr id="2" name="Title 1"/>
+          <p:cNvSpPr>
+            <a:spLocks noGrp="1"/>
+          </p:cNvSpPr>
+          <p:nvPr>
+            <p:ph type="title"/>
+          </p:nvPr>
+        </p:nvSpPr>
+        <p:spPr/>
+        <p:txBody>
+          <a:bodyPr/>
+          <a:lstStyle/>
+          <a:p>
+            <a:pPr lvl="0" indent="0" marL="0">
+              <a:buNone/>
+            </a:pPr>
+            <a:r>
+              <a:rPr/>
+              <a:t>A Horizontal Bar chart</a:t>
+            </a:r>
+          </a:p>
+        </p:txBody>
+      </p:sp>
+      <p:pic>
+        <p:nvPicPr>
+          <p:cNvPr descr="/var/folders/bp/w4c2kztn5fg7yk8vg8k_2wgc0000gn/T/doodlngwzbyw2/svg/barchart_1.png" id="0" name="Picture 1"/>
+          <p:cNvPicPr>
+            <a:picLocks noGrp="1" noChangeAspect="1"/>
+          </p:cNvPicPr>
+          <p:nvPr/>
+        </p:nvPicPr>
+        <p:blipFill>
+          <a:blip r:embed="rId2"/>
+          <a:stretch>
+            <a:fillRect/>
+          </a:stretch>
+        </p:blipFill>
+        <p:spPr bwMode="auto">
+          <a:xfrm>
+            <a:off x="3124200" y="1193800"/>
+            <a:ext cx="2882900" cy="2882900"/>
+          </a:xfrm>
+          <a:prstGeom prst="rect">
+            <a:avLst/>
+          </a:prstGeom>
+          <a:noFill/>
+          <a:ln w="9525">
+            <a:noFill/>
+            <a:headEnd/>
+            <a:tailEnd/>
+          </a:ln>
+        </p:spPr>
+      </p:pic>
+      <p:sp>
+        <p:nvSpPr>
+          <p:cNvPr id="1" name="TextBox 3"/>
+          <p:cNvSpPr txBox="1"/>
+          <p:nvPr>
+            <p:ph idx="1"/>
+          </p:nvPr>
+        </p:nvSpPr>
+        <p:spPr>
+          <a:xfrm>
+            <a:off x="457200" y="4076700"/>
+            <a:ext cx="8229600" cy="508000"/>
+          </a:xfrm>
+          <a:prstGeom prst="rect">
+            <a:avLst/>
+          </a:prstGeom>
+          <a:noFill/>
+        </p:spPr>
+        <p:txBody>
+          <a:bodyPr/>
+          <a:lstStyle/>
+          <a:p>
+            <a:pPr lvl="0" indent="0" marL="0" algn="ctr">
+              <a:buNone/>
+            </a:pPr>
+            <a:r>
+              <a:rPr/>
+              <a:t>&lt;barchart
+data='[
+  { "label": "Apples", "value": 100000000 },
+  { "label": "Bananas", "value": 200000000 },
+  { "label": "Cherries", "value": 150000000 },
+  { "label": "Grapes", "value": 250000000 }
+]'
+  width=500
+  height=500
+  colors='["#FF6700","#008000"]'
+  horizontal='false'
+  moving_average='true'
+  x_label_angle=90
+&gt;</a:t>
+            </a:r>
+          </a:p>
+        </p:txBody>
+      </p:sp>
+    </p:spTree>
+  </p:cSld>
+</p:sld>
+</file>
+
+<file path=ppt/slides/slide17.xml><?xml version="1.0" encoding="utf-8"?>
+<p:sld xmlns:a="http://schemas.openxmlformats.org/drawingml/2006/main" xmlns:r="http://schemas.openxmlformats.org/officeDocument/2006/relationships" xmlns:p="http://schemas.openxmlformats.org/presentationml/2006/main">
+  <p:cSld>
+    <p:spTree>
+      <p:nvGrpSpPr>
+        <p:cNvPr id="1" name=""/>
+        <p:cNvGrpSpPr/>
+        <p:nvPr/>
+      </p:nvGrpSpPr>
+      <p:grpSpPr>
+        <a:xfrm>
+          <a:off x="0" y="0"/>
+          <a:ext cx="0" cy="0"/>
+          <a:chOff x="0" y="0"/>
+          <a:chExt cx="0" cy="0"/>
+        </a:xfrm>
+      </p:grpSpPr>
+      <p:sp>
+        <p:nvSpPr>
+          <p:cNvPr id="2" name="Title 1"/>
+          <p:cNvSpPr>
+            <a:spLocks noGrp="1"/>
+          </p:cNvSpPr>
+          <p:nvPr>
+            <p:ph type="title"/>
+          </p:nvPr>
+        </p:nvSpPr>
+        <p:spPr/>
+        <p:txBody>
+          <a:bodyPr/>
+          <a:lstStyle/>
+          <a:p>
+            <a:pPr lvl="0" indent="0" marL="0">
+              <a:buNone/>
+            </a:pPr>
+            <a:r>
+              <a:rPr/>
+              <a:t>A dotplot chart</a:t>
+            </a:r>
+          </a:p>
+        </p:txBody>
+      </p:sp>
+      <p:pic>
+        <p:nvPicPr>
+          <p:cNvPr descr="/var/folders/bp/w4c2kztn5fg7yk8vg8k_2wgc0000gn/T/doodlngwzbyw2/svg/dotplot_0.png" id="0" name="Picture 1"/>
+          <p:cNvPicPr>
+            <a:picLocks noGrp="1" noChangeAspect="1"/>
+          </p:cNvPicPr>
+          <p:nvPr/>
+        </p:nvPicPr>
+        <p:blipFill>
+          <a:blip r:embed="rId2"/>
+          <a:stretch>
+            <a:fillRect/>
+          </a:stretch>
+        </p:blipFill>
+        <p:spPr bwMode="auto">
+          <a:xfrm>
+            <a:off x="3124200" y="1193800"/>
+            <a:ext cx="2882900" cy="2882900"/>
+          </a:xfrm>
+          <a:prstGeom prst="rect">
+            <a:avLst/>
+          </a:prstGeom>
+          <a:noFill/>
+          <a:ln w="9525">
+            <a:noFill/>
+            <a:headEnd/>
+            <a:tailEnd/>
+          </a:ln>
+        </p:spPr>
+      </p:pic>
+      <p:sp>
+        <p:nvSpPr>
+          <p:cNvPr id="1" name="TextBox 3"/>
+          <p:cNvSpPr txBox="1"/>
+          <p:nvPr>
+            <p:ph idx="1"/>
+          </p:nvPr>
+        </p:nvSpPr>
+        <p:spPr>
+          <a:xfrm>
+            <a:off x="457200" y="4076700"/>
+            <a:ext cx="8229600" cy="508000"/>
+          </a:xfrm>
+          <a:prstGeom prst="rect">
+            <a:avLst/>
+          </a:prstGeom>
+          <a:noFill/>
+        </p:spPr>
+        <p:txBody>
+          <a:bodyPr/>
+          <a:lstStyle/>
+          <a:p>
+            <a:pPr lvl="0" indent="0" marL="0" algn="ctr">
+              <a:buNone/>
+            </a:pPr>
+            <a:r>
+              <a:rPr/>
+              <a:t>&lt;dotplot
+data='[
+    { "category": "A", "value": 10 },
+    { "category": "A", "value": 12 },
+    { "category": "A", "value": 16 },
+    { "category": "B", "value": 20 },
+    { "category": "B", "value": 24 },
+    { "category": "B", "value": 28 },
+    { "category": "C", "value": 12 },
+    { "category": "C", "value": 15 },
+    { "category": "C", "value": 21 }
+]'
+     width=500
+  height=500
+  colors='deep'
+&gt;</a:t>
+            </a:r>
+          </a:p>
+        </p:txBody>
+      </p:sp>
+    </p:spTree>
+  </p:cSld>
+</p:sld>
+</file>
+
+<file path=ppt/slides/slide18.xml><?xml version="1.0" encoding="utf-8"?>
+<p:sld xmlns:a="http://schemas.openxmlformats.org/drawingml/2006/main" xmlns:r="http://schemas.openxmlformats.org/officeDocument/2006/relationships" xmlns:p="http://schemas.openxmlformats.org/presentationml/2006/main">
+  <p:cSld>
+    <p:spTree>
+      <p:nvGrpSpPr>
+        <p:cNvPr id="1" name=""/>
+        <p:cNvGrpSpPr/>
+        <p:nvPr/>
+      </p:nvGrpSpPr>
+      <p:grpSpPr>
+        <a:xfrm>
+          <a:off x="0" y="0"/>
+          <a:ext cx="0" cy="0"/>
+          <a:chOff x="0" y="0"/>
+          <a:chExt cx="0" cy="0"/>
+        </a:xfrm>
+      </p:grpSpPr>
+      <p:sp>
+        <p:nvSpPr>
+          <p:cNvPr id="2" name="Title 1"/>
+          <p:cNvSpPr>
+            <a:spLocks noGrp="1"/>
+          </p:cNvSpPr>
+          <p:nvPr>
+            <p:ph type="title"/>
+          </p:nvPr>
+        </p:nvSpPr>
+        <p:spPr/>
+        <p:txBody>
+          <a:bodyPr/>
+          <a:lstStyle/>
+          <a:p>
+            <a:pPr lvl="0" indent="0" marL="0">
+              <a:buNone/>
+            </a:pPr>
+            <a:r>
+              <a:rPr/>
+              <a:t>A scatterplot chart</a:t>
+            </a:r>
+          </a:p>
+        </p:txBody>
+      </p:sp>
+      <p:pic>
+        <p:nvPicPr>
+          <p:cNvPr descr="/var/folders/bp/w4c2kztn5fg7yk8vg8k_2wgc0000gn/T/doodlngwzbyw2/svg/scatterplot_0.png" id="0" name="Picture 1"/>
+          <p:cNvPicPr>
+            <a:picLocks noGrp="1" noChangeAspect="1"/>
+          </p:cNvPicPr>
+          <p:nvPr/>
+        </p:nvPicPr>
+        <p:blipFill>
+          <a:blip r:embed="rId2"/>
+          <a:stretch>
+            <a:fillRect/>
+          </a:stretch>
+        </p:blipFill>
+        <p:spPr bwMode="auto">
+          <a:xfrm>
+            <a:off x="3124200" y="1193800"/>
+            <a:ext cx="2882900" cy="2882900"/>
+          </a:xfrm>
+          <a:prstGeom prst="rect">
+            <a:avLst/>
+          </a:prstGeom>
+          <a:noFill/>
+          <a:ln w="9525">
+            <a:noFill/>
+            <a:headEnd/>
+            <a:tailEnd/>
+          </a:ln>
+        </p:spPr>
+      </p:pic>
+      <p:sp>
+        <p:nvSpPr>
+          <p:cNvPr id="1" name="TextBox 3"/>
+          <p:cNvSpPr txBox="1"/>
+          <p:nvPr>
+            <p:ph idx="1"/>
+          </p:nvPr>
+        </p:nvSpPr>
+        <p:spPr>
+          <a:xfrm>
+            <a:off x="457200" y="4076700"/>
+            <a:ext cx="8229600" cy="508000"/>
+          </a:xfrm>
+          <a:prstGeom prst="rect">
+            <a:avLst/>
+          </a:prstGeom>
+          <a:noFill/>
+        </p:spPr>
+        <p:txBody>
+          <a:bodyPr/>
+          <a:lstStyle/>
+          <a:p>
+            <a:pPr lvl="0" indent="0" marL="0" algn="ctr">
+              <a:buNone/>
+            </a:pPr>
+            <a:r>
+              <a:rPr/>
+              <a:t>&lt;scatterplot
+data='[
+     { "x": 10, "y": 20 },
+  { "x": 30, "y": 40 },
+  { "x": 50, "y": 60 }
+]'
+     width=500
+  height=500
+  dotsize=8
+&gt;</a:t>
+            </a:r>
+          </a:p>
+        </p:txBody>
+      </p:sp>
+    </p:spTree>
+  </p:cSld>
+</p:sld>
+</file>
+
+<file path=ppt/slides/slide19.xml><?xml version="1.0" encoding="utf-8"?>
+<p:sld xmlns:a="http://schemas.openxmlformats.org/drawingml/2006/main" xmlns:r="http://schemas.openxmlformats.org/officeDocument/2006/relationships" xmlns:p="http://schemas.openxmlformats.org/presentationml/2006/main">
+  <p:cSld>
+    <p:spTree>
+      <p:nvGrpSpPr>
+        <p:cNvPr id="1" name=""/>
+        <p:cNvGrpSpPr/>
+        <p:nvPr/>
+      </p:nvGrpSpPr>
+      <p:grpSpPr>
+        <a:xfrm>
+          <a:off x="0" y="0"/>
+          <a:ext cx="0" cy="0"/>
+          <a:chOff x="0" y="0"/>
+          <a:chExt cx="0" cy="0"/>
+        </a:xfrm>
+      </p:grpSpPr>
+      <p:pic>
+        <p:nvPicPr>
+          <p:cNvPr descr="/var/folders/bp/w4c2kztn5fg7yk8vg8k_2wgc0000gn/T/doodlngwzbyw2/svg/scatterplot_1.png" id="0" name="Picture 1"/>
+          <p:cNvPicPr>
+            <a:picLocks noGrp="1" noChangeAspect="1"/>
+          </p:cNvPicPr>
+          <p:nvPr/>
+        </p:nvPicPr>
+        <p:blipFill>
+          <a:blip r:embed="rId2"/>
+          <a:stretch>
+            <a:fillRect/>
+          </a:stretch>
+        </p:blipFill>
+        <p:spPr bwMode="auto">
+          <a:xfrm>
+            <a:off x="3124200" y="1193800"/>
+            <a:ext cx="2882900" cy="2882900"/>
+          </a:xfrm>
+          <a:prstGeom prst="rect">
+            <a:avLst/>
+          </a:prstGeom>
+          <a:noFill/>
+          <a:ln w="9525">
+            <a:noFill/>
+            <a:headEnd/>
+            <a:tailEnd/>
+          </a:ln>
+        </p:spPr>
+      </p:pic>
+      <p:sp>
+        <p:nvSpPr>
+          <p:cNvPr id="1" name="TextBox 3"/>
+          <p:cNvSpPr txBox="1"/>
+          <p:nvPr>
+            <p:ph idx="1"/>
+          </p:nvPr>
+        </p:nvSpPr>
+        <p:spPr>
+          <a:xfrm>
+            <a:off x="457200" y="4076700"/>
+            <a:ext cx="8229600" cy="508000"/>
+          </a:xfrm>
+          <a:prstGeom prst="rect">
+            <a:avLst/>
+          </a:prstGeom>
+          <a:noFill/>
+        </p:spPr>
+        <p:txBody>
+          <a:bodyPr/>
+          <a:lstStyle/>
+          <a:p>
+            <a:pPr lvl="0" indent="0" marL="0" algn="ctr">
+              <a:buNone/>
+            </a:pPr>
+            <a:r>
+              <a:rPr/>
+              <a:t>&lt;scatterplot
+data='[
+     { "x": 10, "y": 20 },
+  { "x": 30, "y": 40 },
+  { "x": 50, "y": 60 }
+]'
+    width=500
+  height=500
 &gt;</a:t>
             </a:r>
           </a:p>
@@ -3605,14 +4432,14 @@
             </a:pPr>
             <a:r>
               <a:rPr/>
-              <a:t>A Horizontal Bar chart</a:t>
+              <a:t>A HORIZONTAL radial_areachart</a:t>
             </a:r>
           </a:p>
         </p:txBody>
       </p:sp>
       <p:pic>
         <p:nvPicPr>
-          <p:cNvPr descr="/var/folders/bp/w4c2kztn5fg7yk8vg8k_2wgc0000gn/T/doodlcat3f6my/svg/barchart_1.png" id="0" name="Picture 1"/>
+          <p:cNvPr descr="/var/folders/bp/w4c2kztn5fg7yk8vg8k_2wgc0000gn/T/doodlngwzbyw2/svg/radial_areachart_0.png" id="0" name="Picture 1"/>
           <p:cNvPicPr>
             <a:picLocks noGrp="1" noChangeAspect="1"/>
           </p:cNvPicPr>
@@ -3626,8 +4453,8 @@
         </p:blipFill>
         <p:spPr bwMode="auto">
           <a:xfrm>
-            <a:off x="3124200" y="1193800"/>
-            <a:ext cx="2882900" cy="2882900"/>
+            <a:off x="3009900" y="1193800"/>
+            <a:ext cx="3136900" cy="2882900"/>
           </a:xfrm>
           <a:prstGeom prst="rect">
             <a:avLst/>
@@ -3667,17 +4494,1163 @@
             </a:pPr>
             <a:r>
               <a:rPr/>
-              <a:t>&lt;barchart
+              <a:t>&lt;radial_areachart
+  data='[
+  { "group": "North", "label": "Q1", "value": 22 },
+  { "group": "North", "label": "Q2", "value": 35 },
+  { "group": "North", "label": "Q3", "value": 40 },
+  { "group": "North", "label": "Q4", "value": 28 },
+  { "group": "South", "label": "Q1", "value": 18 },
+  { "group": "South", "label": "Q2", "value": 30 },
+  { "group": "South", "label": "Q3", "value": 26 },
+  { "group": "South", "label": "Q4", "value": 32 },
+  { "group": "East", "label": "Q1", "value": 25 },
+  { "group": "East", "label": "Q2", "value": 28 },
+  { "group": "East", "label": "Q3", "value": 33 },
+  { "group": "East", "label": "Q4", "value": 29 },
+  { "group": "West", "label": "Q1", "value": 20 },
+  { "group": "West", "label": "Q2", "value": 24 },
+  { "group": "West", "label": "Q3", "value": 32 },
+  { "group": "West", "label": "Q4", "value": 27 }
+]'
+  width=500
+  height=400
+  colors='deep'
+  x_label_angle=90
+  show_legend='true'
+  horizontal='true'
+&gt;</a:t>
+            </a:r>
+          </a:p>
+        </p:txBody>
+      </p:sp>
+    </p:spTree>
+  </p:cSld>
+</p:sld>
+</file>
+
+<file path=ppt/slides/slide20.xml><?xml version="1.0" encoding="utf-8"?>
+<p:sld xmlns:a="http://schemas.openxmlformats.org/drawingml/2006/main" xmlns:r="http://schemas.openxmlformats.org/officeDocument/2006/relationships" xmlns:p="http://schemas.openxmlformats.org/presentationml/2006/main">
+  <p:cSld>
+    <p:spTree>
+      <p:nvGrpSpPr>
+        <p:cNvPr id="1" name=""/>
+        <p:cNvGrpSpPr/>
+        <p:nvPr/>
+      </p:nvGrpSpPr>
+      <p:grpSpPr>
+        <a:xfrm>
+          <a:off x="0" y="0"/>
+          <a:ext cx="0" cy="0"/>
+          <a:chOff x="0" y="0"/>
+          <a:chExt cx="0" cy="0"/>
+        </a:xfrm>
+      </p:grpSpPr>
+      <p:sp>
+        <p:nvSpPr>
+          <p:cNvPr id="2" name="Title 1"/>
+          <p:cNvSpPr>
+            <a:spLocks noGrp="1"/>
+          </p:cNvSpPr>
+          <p:nvPr>
+            <p:ph type="title"/>
+          </p:nvPr>
+        </p:nvSpPr>
+        <p:spPr/>
+        <p:txBody>
+          <a:bodyPr/>
+          <a:lstStyle/>
+          <a:p>
+            <a:pPr lvl="0" indent="0" marL="0">
+              <a:buNone/>
+            </a:pPr>
+            <a:r>
+              <a:rPr/>
+              <a:t>A boxplot chart</a:t>
+            </a:r>
+          </a:p>
+        </p:txBody>
+      </p:sp>
+      <p:pic>
+        <p:nvPicPr>
+          <p:cNvPr descr="/var/folders/bp/w4c2kztn5fg7yk8vg8k_2wgc0000gn/T/doodlngwzbyw2/svg/boxplot_0.png" id="0" name="Picture 1"/>
+          <p:cNvPicPr>
+            <a:picLocks noGrp="1" noChangeAspect="1"/>
+          </p:cNvPicPr>
+          <p:nvPr/>
+        </p:nvPicPr>
+        <p:blipFill>
+          <a:blip r:embed="rId2"/>
+          <a:stretch>
+            <a:fillRect/>
+          </a:stretch>
+        </p:blipFill>
+        <p:spPr bwMode="auto">
+          <a:xfrm>
+            <a:off x="3124200" y="1193800"/>
+            <a:ext cx="2882900" cy="2882900"/>
+          </a:xfrm>
+          <a:prstGeom prst="rect">
+            <a:avLst/>
+          </a:prstGeom>
+          <a:noFill/>
+          <a:ln w="9525">
+            <a:noFill/>
+            <a:headEnd/>
+            <a:tailEnd/>
+          </a:ln>
+        </p:spPr>
+      </p:pic>
+      <p:sp>
+        <p:nvSpPr>
+          <p:cNvPr id="1" name="TextBox 3"/>
+          <p:cNvSpPr txBox="1"/>
+          <p:nvPr>
+            <p:ph idx="1"/>
+          </p:nvPr>
+        </p:nvSpPr>
+        <p:spPr>
+          <a:xfrm>
+            <a:off x="457200" y="4076700"/>
+            <a:ext cx="8229600" cy="508000"/>
+          </a:xfrm>
+          <a:prstGeom prst="rect">
+            <a:avLst/>
+          </a:prstGeom>
+          <a:noFill/>
+        </p:spPr>
+        <p:txBody>
+          <a:bodyPr/>
+          <a:lstStyle/>
+          <a:p>
+            <a:pPr lvl="0" indent="0" marL="0" algn="ctr">
+              <a:buNone/>
+            </a:pPr>
+            <a:r>
+              <a:rPr/>
+              <a:t>&lt;boxplot
 data='[
-  { "label": "Apples", "value": 100000000 },
-  { "label": "Bananas", "value": 200000000 },
-  { "label": "Cherries", "value": 150000000 },
-  { "label": "Grapes", "value": 250000000 }
+   { "category": "A", "value": 10 },
+  { "category": "A", "value": 15 },
+  { "category": "A", "value": 20 },
+  { "category": "B", "value": 30 },
+  { "category": "B", "value": 35 },
+  { "category": "B", "value": 40 }
 ]'
-  size='{"width":500,"height":500}'
-  colors='["#FF6700","#008000"]'
-  horizontal='false'
-  moving_average='true'
+     width=500
+  height=500
+  colors='deep'
+&gt;</a:t>
+            </a:r>
+          </a:p>
+        </p:txBody>
+      </p:sp>
+    </p:spTree>
+  </p:cSld>
+</p:sld>
+</file>
+
+<file path=ppt/slides/slide21.xml><?xml version="1.0" encoding="utf-8"?>
+<p:sld xmlns:a="http://schemas.openxmlformats.org/drawingml/2006/main" xmlns:r="http://schemas.openxmlformats.org/officeDocument/2006/relationships" xmlns:p="http://schemas.openxmlformats.org/presentationml/2006/main">
+  <p:cSld>
+    <p:spTree>
+      <p:nvGrpSpPr>
+        <p:cNvPr id="1" name=""/>
+        <p:cNvGrpSpPr/>
+        <p:nvPr/>
+      </p:nvGrpSpPr>
+      <p:grpSpPr>
+        <a:xfrm>
+          <a:off x="0" y="0"/>
+          <a:ext cx="0" cy="0"/>
+          <a:chOff x="0" y="0"/>
+          <a:chExt cx="0" cy="0"/>
+        </a:xfrm>
+      </p:grpSpPr>
+      <p:sp>
+        <p:nvSpPr>
+          <p:cNvPr id="2" name="Title 1"/>
+          <p:cNvSpPr>
+            <a:spLocks noGrp="1"/>
+          </p:cNvSpPr>
+          <p:nvPr>
+            <p:ph type="title"/>
+          </p:nvPr>
+        </p:nvSpPr>
+        <p:spPr/>
+        <p:txBody>
+          <a:bodyPr/>
+          <a:lstStyle/>
+          <a:p>
+            <a:pPr lvl="0" indent="0" marL="0">
+              <a:buNone/>
+            </a:pPr>
+            <a:r>
+              <a:rPr/>
+              <a:t>A Contour diagramn</a:t>
+            </a:r>
+          </a:p>
+        </p:txBody>
+      </p:sp>
+      <p:pic>
+        <p:nvPicPr>
+          <p:cNvPr descr="/var/folders/bp/w4c2kztn5fg7yk8vg8k_2wgc0000gn/T/doodlngwzbyw2/svg/contour_0.png" id="0" name="Picture 1"/>
+          <p:cNvPicPr>
+            <a:picLocks noGrp="1" noChangeAspect="1"/>
+          </p:cNvPicPr>
+          <p:nvPr/>
+        </p:nvPicPr>
+        <p:blipFill>
+          <a:blip r:embed="rId2"/>
+          <a:stretch>
+            <a:fillRect/>
+          </a:stretch>
+        </p:blipFill>
+        <p:spPr bwMode="auto">
+          <a:xfrm>
+            <a:off x="3124200" y="1193800"/>
+            <a:ext cx="2882900" cy="2882900"/>
+          </a:xfrm>
+          <a:prstGeom prst="rect">
+            <a:avLst/>
+          </a:prstGeom>
+          <a:noFill/>
+          <a:ln w="9525">
+            <a:noFill/>
+            <a:headEnd/>
+            <a:tailEnd/>
+          </a:ln>
+        </p:spPr>
+      </p:pic>
+      <p:sp>
+        <p:nvSpPr>
+          <p:cNvPr id="1" name="TextBox 3"/>
+          <p:cNvSpPr txBox="1"/>
+          <p:nvPr>
+            <p:ph idx="1"/>
+          </p:nvPr>
+        </p:nvSpPr>
+        <p:spPr>
+          <a:xfrm>
+            <a:off x="457200" y="4076700"/>
+            <a:ext cx="8229600" cy="508000"/>
+          </a:xfrm>
+          <a:prstGeom prst="rect">
+            <a:avLst/>
+          </a:prstGeom>
+          <a:noFill/>
+        </p:spPr>
+        <p:txBody>
+          <a:bodyPr/>
+          <a:lstStyle/>
+          <a:p>
+            <a:pPr lvl="0" indent="0" marL="0" algn="ctr">
+              <a:buNone/>
+            </a:pPr>
+            <a:r>
+              <a:rPr/>
+              <a:t>&lt;contour
+data='[
+  [0, 10, 20, 30, 20],
+  [10, 20, 30, 40, 30],
+  [20, 30, 40, 50, 40],
+  [10, 20, 30, 40, 30],
+  [0, 10, 20, 30, 20]
+]'
+   width=500
+  height=500
+  colors='flare'
+&gt;</a:t>
+            </a:r>
+          </a:p>
+        </p:txBody>
+      </p:sp>
+    </p:spTree>
+  </p:cSld>
+</p:sld>
+</file>
+
+<file path=ppt/slides/slide22.xml><?xml version="1.0" encoding="utf-8"?>
+<p:sld xmlns:a="http://schemas.openxmlformats.org/drawingml/2006/main" xmlns:r="http://schemas.openxmlformats.org/officeDocument/2006/relationships" xmlns:p="http://schemas.openxmlformats.org/presentationml/2006/main">
+  <p:cSld>
+    <p:spTree>
+      <p:nvGrpSpPr>
+        <p:cNvPr id="1" name=""/>
+        <p:cNvGrpSpPr/>
+        <p:nvPr/>
+      </p:nvGrpSpPr>
+      <p:grpSpPr>
+        <a:xfrm>
+          <a:off x="0" y="0"/>
+          <a:ext cx="0" cy="0"/>
+          <a:chOff x="0" y="0"/>
+          <a:chExt cx="0" cy="0"/>
+        </a:xfrm>
+      </p:grpSpPr>
+      <p:pic>
+        <p:nvPicPr>
+          <p:cNvPr descr="/var/folders/bp/w4c2kztn5fg7yk8vg8k_2wgc0000gn/T/doodlngwzbyw2/svg/skey_0.png" id="0" name="Picture 1"/>
+          <p:cNvPicPr>
+            <a:picLocks noGrp="1" noChangeAspect="1"/>
+          </p:cNvPicPr>
+          <p:nvPr/>
+        </p:nvPicPr>
+        <p:blipFill>
+          <a:blip r:embed="rId2"/>
+          <a:stretch>
+            <a:fillRect/>
+          </a:stretch>
+        </p:blipFill>
+        <p:spPr bwMode="auto">
+          <a:xfrm>
+            <a:off x="1689100" y="1193800"/>
+            <a:ext cx="5765800" cy="2882900"/>
+          </a:xfrm>
+          <a:prstGeom prst="rect">
+            <a:avLst/>
+          </a:prstGeom>
+          <a:noFill/>
+          <a:ln w="9525">
+            <a:noFill/>
+            <a:headEnd/>
+            <a:tailEnd/>
+          </a:ln>
+        </p:spPr>
+      </p:pic>
+      <p:sp>
+        <p:nvSpPr>
+          <p:cNvPr id="1" name="TextBox 3"/>
+          <p:cNvSpPr txBox="1"/>
+          <p:nvPr>
+            <p:ph idx="1"/>
+          </p:nvPr>
+        </p:nvSpPr>
+        <p:spPr>
+          <a:xfrm>
+            <a:off x="457200" y="4076700"/>
+            <a:ext cx="8229600" cy="508000"/>
+          </a:xfrm>
+          <a:prstGeom prst="rect">
+            <a:avLst/>
+          </a:prstGeom>
+          <a:noFill/>
+        </p:spPr>
+        <p:txBody>
+          <a:bodyPr/>
+          <a:lstStyle/>
+          <a:p>
+            <a:pPr lvl="0" indent="0" marL="0" algn="ctr">
+              <a:buNone/>
+            </a:pPr>
+            <a:r>
+              <a:rPr/>
+              <a:t>&lt;skey
+ path= "data/std_focus.json"
+    link_color='"target"'
+    colors='cc.glasbey'
+    width=1000
+  height=500&gt;</a:t>
+            </a:r>
+          </a:p>
+        </p:txBody>
+      </p:sp>
+    </p:spTree>
+  </p:cSld>
+</p:sld>
+</file>
+
+<file path=ppt/slides/slide23.xml><?xml version="1.0" encoding="utf-8"?>
+<p:sld xmlns:a="http://schemas.openxmlformats.org/drawingml/2006/main" xmlns:r="http://schemas.openxmlformats.org/officeDocument/2006/relationships" xmlns:p="http://schemas.openxmlformats.org/presentationml/2006/main">
+  <p:cSld>
+    <p:spTree>
+      <p:nvGrpSpPr>
+        <p:cNvPr id="1" name=""/>
+        <p:cNvGrpSpPr/>
+        <p:nvPr/>
+      </p:nvGrpSpPr>
+      <p:grpSpPr>
+        <a:xfrm>
+          <a:off x="0" y="0"/>
+          <a:ext cx="0" cy="0"/>
+          <a:chOff x="0" y="0"/>
+          <a:chExt cx="0" cy="0"/>
+        </a:xfrm>
+      </p:grpSpPr>
+      <p:pic>
+        <p:nvPicPr>
+          <p:cNvPr descr="/var/folders/bp/w4c2kztn5fg7yk8vg8k_2wgc0000gn/T/doodlngwzbyw2/svg/skey_1.png" id="0" name="Picture 1"/>
+          <p:cNvPicPr>
+            <a:picLocks noGrp="1" noChangeAspect="1"/>
+          </p:cNvPicPr>
+          <p:nvPr/>
+        </p:nvPicPr>
+        <p:blipFill>
+          <a:blip r:embed="rId2"/>
+          <a:stretch>
+            <a:fillRect/>
+          </a:stretch>
+        </p:blipFill>
+        <p:spPr bwMode="auto">
+          <a:xfrm>
+            <a:off x="723900" y="1193800"/>
+            <a:ext cx="7683500" cy="2882900"/>
+          </a:xfrm>
+          <a:prstGeom prst="rect">
+            <a:avLst/>
+          </a:prstGeom>
+          <a:noFill/>
+          <a:ln w="9525">
+            <a:noFill/>
+            <a:headEnd/>
+            <a:tailEnd/>
+          </a:ln>
+        </p:spPr>
+      </p:pic>
+      <p:sp>
+        <p:nvSpPr>
+          <p:cNvPr id="1" name="TextBox 3"/>
+          <p:cNvSpPr txBox="1"/>
+          <p:nvPr>
+            <p:ph idx="1"/>
+          </p:nvPr>
+        </p:nvSpPr>
+        <p:spPr>
+          <a:xfrm>
+            <a:off x="457200" y="4076700"/>
+            <a:ext cx="8229600" cy="508000"/>
+          </a:xfrm>
+          <a:prstGeom prst="rect">
+            <a:avLst/>
+          </a:prstGeom>
+          <a:noFill/>
+        </p:spPr>
+        <p:txBody>
+          <a:bodyPr/>
+          <a:lstStyle/>
+          <a:p>
+            <a:pPr lvl="0" indent="0" marL="0" algn="ctr">
+              <a:buNone/>
+            </a:pPr>
+            <a:r>
+              <a:rPr/>
+              <a:t>&lt;skey
+  width=600
+  height=225
+  path= "data/energy.json"
+  n_colors=10
+  colors='pastel'
+  link_color='"source-target"'
+  node_align='"right"'
+&gt;</a:t>
+            </a:r>
+          </a:p>
+        </p:txBody>
+      </p:sp>
+    </p:spTree>
+  </p:cSld>
+</p:sld>
+</file>
+
+<file path=ppt/slides/slide24.xml><?xml version="1.0" encoding="utf-8"?>
+<p:sld xmlns:a="http://schemas.openxmlformats.org/drawingml/2006/main" xmlns:r="http://schemas.openxmlformats.org/officeDocument/2006/relationships" xmlns:p="http://schemas.openxmlformats.org/presentationml/2006/main">
+  <p:cSld>
+    <p:spTree>
+      <p:nvGrpSpPr>
+        <p:cNvPr id="1" name=""/>
+        <p:cNvGrpSpPr/>
+        <p:nvPr/>
+      </p:nvGrpSpPr>
+      <p:grpSpPr>
+        <a:xfrm>
+          <a:off x="0" y="0"/>
+          <a:ext cx="0" cy="0"/>
+          <a:chOff x="0" y="0"/>
+          <a:chExt cx="0" cy="0"/>
+        </a:xfrm>
+      </p:grpSpPr>
+      <p:sp>
+        <p:nvSpPr>
+          <p:cNvPr id="2" name="Title 1"/>
+          <p:cNvSpPr>
+            <a:spLocks noGrp="1"/>
+          </p:cNvSpPr>
+          <p:nvPr>
+            <p:ph type="title"/>
+          </p:nvPr>
+        </p:nvSpPr>
+        <p:spPr/>
+        <p:txBody>
+          <a:bodyPr/>
+          <a:lstStyle/>
+          <a:p>
+            <a:pPr lvl="0" indent="0" marL="0">
+              <a:buNone/>
+            </a:pPr>
+            <a:r>
+              <a:rPr/>
+              <a:t>A Pie chart from data file format</a:t>
+            </a:r>
+          </a:p>
+        </p:txBody>
+      </p:sp>
+      <p:pic>
+        <p:nvPicPr>
+          <p:cNvPr descr="/var/folders/bp/w4c2kztn5fg7yk8vg8k_2wgc0000gn/T/doodlngwzbyw2/svg/piechart_0.png" id="0" name="Picture 1"/>
+          <p:cNvPicPr>
+            <a:picLocks noGrp="1" noChangeAspect="1"/>
+          </p:cNvPicPr>
+          <p:nvPr/>
+        </p:nvPicPr>
+        <p:blipFill>
+          <a:blip r:embed="rId2"/>
+          <a:stretch>
+            <a:fillRect/>
+          </a:stretch>
+        </p:blipFill>
+        <p:spPr bwMode="auto">
+          <a:xfrm>
+            <a:off x="3124200" y="1193800"/>
+            <a:ext cx="2882900" cy="2882900"/>
+          </a:xfrm>
+          <a:prstGeom prst="rect">
+            <a:avLst/>
+          </a:prstGeom>
+          <a:noFill/>
+          <a:ln w="9525">
+            <a:noFill/>
+            <a:headEnd/>
+            <a:tailEnd/>
+          </a:ln>
+        </p:spPr>
+      </p:pic>
+      <p:sp>
+        <p:nvSpPr>
+          <p:cNvPr id="1" name="TextBox 3"/>
+          <p:cNvSpPr txBox="1"/>
+          <p:nvPr>
+            <p:ph idx="1"/>
+          </p:nvPr>
+        </p:nvSpPr>
+        <p:spPr>
+          <a:xfrm>
+            <a:off x="457200" y="4076700"/>
+            <a:ext cx="8229600" cy="508000"/>
+          </a:xfrm>
+          <a:prstGeom prst="rect">
+            <a:avLst/>
+          </a:prstGeom>
+          <a:noFill/>
+        </p:spPr>
+        <p:txBody>
+          <a:bodyPr/>
+          <a:lstStyle/>
+          <a:p>
+            <a:pPr lvl="0" indent="0" marL="0" algn="ctr">
+              <a:buNone/>
+            </a:pPr>
+            <a:r>
+              <a:rPr/>
+              <a:t>&lt;piechart
+  path="data/pie.json"
+  width=900
+  height=900
+  colors='deep'
+&gt;</a:t>
+            </a:r>
+          </a:p>
+        </p:txBody>
+      </p:sp>
+    </p:spTree>
+  </p:cSld>
+</p:sld>
+</file>
+
+<file path=ppt/slides/slide25.xml><?xml version="1.0" encoding="utf-8"?>
+<p:sld xmlns:a="http://schemas.openxmlformats.org/drawingml/2006/main" xmlns:r="http://schemas.openxmlformats.org/officeDocument/2006/relationships" xmlns:p="http://schemas.openxmlformats.org/presentationml/2006/main">
+  <p:cSld>
+    <p:spTree>
+      <p:nvGrpSpPr>
+        <p:cNvPr id="1" name=""/>
+        <p:cNvGrpSpPr/>
+        <p:nvPr/>
+      </p:nvGrpSpPr>
+      <p:grpSpPr>
+        <a:xfrm>
+          <a:off x="0" y="0"/>
+          <a:ext cx="0" cy="0"/>
+          <a:chOff x="0" y="0"/>
+          <a:chExt cx="0" cy="0"/>
+        </a:xfrm>
+      </p:grpSpPr>
+      <p:sp>
+        <p:nvSpPr>
+          <p:cNvPr id="2" name="Title 1"/>
+          <p:cNvSpPr>
+            <a:spLocks noGrp="1"/>
+          </p:cNvSpPr>
+          <p:nvPr>
+            <p:ph type="title"/>
+          </p:nvPr>
+        </p:nvSpPr>
+        <p:spPr/>
+        <p:txBody>
+          <a:bodyPr/>
+          <a:lstStyle/>
+          <a:p>
+            <a:pPr lvl="0" indent="0" marL="0">
+              <a:buNone/>
+            </a:pPr>
+            <a:r>
+              <a:rPr/>
+              <a:t>A Pie chart from data path format</a:t>
+            </a:r>
+          </a:p>
+        </p:txBody>
+      </p:sp>
+      <p:pic>
+        <p:nvPicPr>
+          <p:cNvPr descr="/var/folders/bp/w4c2kztn5fg7yk8vg8k_2wgc0000gn/T/doodlngwzbyw2/svg/piechart_1.png" id="0" name="Picture 1"/>
+          <p:cNvPicPr>
+            <a:picLocks noGrp="1" noChangeAspect="1"/>
+          </p:cNvPicPr>
+          <p:nvPr/>
+        </p:nvPicPr>
+        <p:blipFill>
+          <a:blip r:embed="rId2"/>
+          <a:stretch>
+            <a:fillRect/>
+          </a:stretch>
+        </p:blipFill>
+        <p:spPr bwMode="auto">
+          <a:xfrm>
+            <a:off x="3124200" y="1193800"/>
+            <a:ext cx="2882900" cy="2882900"/>
+          </a:xfrm>
+          <a:prstGeom prst="rect">
+            <a:avLst/>
+          </a:prstGeom>
+          <a:noFill/>
+          <a:ln w="9525">
+            <a:noFill/>
+            <a:headEnd/>
+            <a:tailEnd/>
+          </a:ln>
+        </p:spPr>
+      </p:pic>
+      <p:sp>
+        <p:nvSpPr>
+          <p:cNvPr id="1" name="TextBox 3"/>
+          <p:cNvSpPr txBox="1"/>
+          <p:nvPr>
+            <p:ph idx="1"/>
+          </p:nvPr>
+        </p:nvSpPr>
+        <p:spPr>
+          <a:xfrm>
+            <a:off x="457200" y="4076700"/>
+            <a:ext cx="8229600" cy="508000"/>
+          </a:xfrm>
+          <a:prstGeom prst="rect">
+            <a:avLst/>
+          </a:prstGeom>
+          <a:noFill/>
+        </p:spPr>
+        <p:txBody>
+          <a:bodyPr/>
+          <a:lstStyle/>
+          <a:p>
+            <a:pPr lvl="0" indent="0" marL="0" algn="ctr">
+              <a:buNone/>
+            </a:pPr>
+            <a:r>
+              <a:rPr/>
+              <a:t>&lt;piechart
+  path="data/pie.json"
+  width="900"
+  height="900"
+  colors='deep'
+&gt;</a:t>
+            </a:r>
+          </a:p>
+        </p:txBody>
+      </p:sp>
+    </p:spTree>
+  </p:cSld>
+</p:sld>
+</file>
+
+<file path=ppt/slides/slide26.xml><?xml version="1.0" encoding="utf-8"?>
+<p:sld xmlns:a="http://schemas.openxmlformats.org/drawingml/2006/main" xmlns:r="http://schemas.openxmlformats.org/officeDocument/2006/relationships" xmlns:p="http://schemas.openxmlformats.org/presentationml/2006/main">
+  <p:cSld>
+    <p:spTree>
+      <p:nvGrpSpPr>
+        <p:cNvPr id="1" name=""/>
+        <p:cNvGrpSpPr/>
+        <p:nvPr/>
+      </p:nvGrpSpPr>
+      <p:grpSpPr>
+        <a:xfrm>
+          <a:off x="0" y="0"/>
+          <a:ext cx="0" cy="0"/>
+          <a:chOff x="0" y="0"/>
+          <a:chExt cx="0" cy="0"/>
+        </a:xfrm>
+      </p:grpSpPr>
+      <p:sp>
+        <p:nvSpPr>
+          <p:cNvPr id="2" name="Title 1"/>
+          <p:cNvSpPr>
+            <a:spLocks noGrp="1"/>
+          </p:cNvSpPr>
+          <p:nvPr>
+            <p:ph type="title"/>
+          </p:nvPr>
+        </p:nvSpPr>
+        <p:spPr/>
+        <p:txBody>
+          <a:bodyPr/>
+          <a:lstStyle/>
+          <a:p>
+            <a:pPr lvl="0" indent="0" marL="0">
+              <a:buNone/>
+            </a:pPr>
+            <a:r>
+              <a:rPr/>
+              <a:t>A Pie chart from data path with format</a:t>
+            </a:r>
+          </a:p>
+        </p:txBody>
+      </p:sp>
+      <p:pic>
+        <p:nvPicPr>
+          <p:cNvPr descr="/var/folders/bp/w4c2kztn5fg7yk8vg8k_2wgc0000gn/T/doodlngwzbyw2/svg/piechart_2.png" id="0" name="Picture 1"/>
+          <p:cNvPicPr>
+            <a:picLocks noGrp="1" noChangeAspect="1"/>
+          </p:cNvPicPr>
+          <p:nvPr/>
+        </p:nvPicPr>
+        <p:blipFill>
+          <a:blip r:embed="rId2"/>
+          <a:stretch>
+            <a:fillRect/>
+          </a:stretch>
+        </p:blipFill>
+        <p:spPr bwMode="auto">
+          <a:xfrm>
+            <a:off x="3124200" y="1193800"/>
+            <a:ext cx="2882900" cy="2882900"/>
+          </a:xfrm>
+          <a:prstGeom prst="rect">
+            <a:avLst/>
+          </a:prstGeom>
+          <a:noFill/>
+          <a:ln w="9525">
+            <a:noFill/>
+            <a:headEnd/>
+            <a:tailEnd/>
+          </a:ln>
+        </p:spPr>
+      </p:pic>
+      <p:sp>
+        <p:nvSpPr>
+          <p:cNvPr id="1" name="TextBox 3"/>
+          <p:cNvSpPr txBox="1"/>
+          <p:nvPr>
+            <p:ph idx="1"/>
+          </p:nvPr>
+        </p:nvSpPr>
+        <p:spPr>
+          <a:xfrm>
+            <a:off x="457200" y="4076700"/>
+            <a:ext cx="8229600" cy="508000"/>
+          </a:xfrm>
+          <a:prstGeom prst="rect">
+            <a:avLst/>
+          </a:prstGeom>
+          <a:noFill/>
+        </p:spPr>
+        <p:txBody>
+          <a:bodyPr/>
+          <a:lstStyle/>
+          <a:p>
+            <a:pPr lvl="0" indent="0" marL="0" algn="ctr">
+              <a:buNone/>
+            </a:pPr>
+            <a:r>
+              <a:rPr/>
+              <a:t>&lt;piechart
+  path="data/pie.json"
+  format="json"
+  width=500
+  height=500
+  colors='deep'
+&gt;</a:t>
+            </a:r>
+          </a:p>
+        </p:txBody>
+      </p:sp>
+    </p:spTree>
+  </p:cSld>
+</p:sld>
+</file>
+
+<file path=ppt/slides/slide27.xml><?xml version="1.0" encoding="utf-8"?>
+<p:sld xmlns:a="http://schemas.openxmlformats.org/drawingml/2006/main" xmlns:r="http://schemas.openxmlformats.org/officeDocument/2006/relationships" xmlns:p="http://schemas.openxmlformats.org/presentationml/2006/main">
+  <p:cSld>
+    <p:spTree>
+      <p:nvGrpSpPr>
+        <p:cNvPr id="1" name=""/>
+        <p:cNvGrpSpPr/>
+        <p:nvPr/>
+      </p:nvGrpSpPr>
+      <p:grpSpPr>
+        <a:xfrm>
+          <a:off x="0" y="0"/>
+          <a:ext cx="0" cy="0"/>
+          <a:chOff x="0" y="0"/>
+          <a:chExt cx="0" cy="0"/>
+        </a:xfrm>
+      </p:grpSpPr>
+      <p:sp>
+        <p:nvSpPr>
+          <p:cNvPr id="2" name="Title 1"/>
+          <p:cNvSpPr>
+            <a:spLocks noGrp="1"/>
+          </p:cNvSpPr>
+          <p:nvPr>
+            <p:ph type="title"/>
+          </p:nvPr>
+        </p:nvSpPr>
+        <p:spPr/>
+        <p:txBody>
+          <a:bodyPr/>
+          <a:lstStyle/>
+          <a:p>
+            <a:pPr lvl="0" indent="0" marL="0">
+              <a:buNone/>
+            </a:pPr>
+            <a:r>
+              <a:rPr/>
+              <a:t>A Donut chart</a:t>
+            </a:r>
+          </a:p>
+        </p:txBody>
+      </p:sp>
+      <p:pic>
+        <p:nvPicPr>
+          <p:cNvPr descr="/var/folders/bp/w4c2kztn5fg7yk8vg8k_2wgc0000gn/T/doodlngwzbyw2/svg/piechart_3.png" id="0" name="Picture 1"/>
+          <p:cNvPicPr>
+            <a:picLocks noGrp="1" noChangeAspect="1"/>
+          </p:cNvPicPr>
+          <p:nvPr/>
+        </p:nvPicPr>
+        <p:blipFill>
+          <a:blip r:embed="rId2"/>
+          <a:stretch>
+            <a:fillRect/>
+          </a:stretch>
+        </p:blipFill>
+        <p:spPr bwMode="auto">
+          <a:xfrm>
+            <a:off x="3124200" y="1193800"/>
+            <a:ext cx="2882900" cy="2882900"/>
+          </a:xfrm>
+          <a:prstGeom prst="rect">
+            <a:avLst/>
+          </a:prstGeom>
+          <a:noFill/>
+          <a:ln w="9525">
+            <a:noFill/>
+            <a:headEnd/>
+            <a:tailEnd/>
+          </a:ln>
+        </p:spPr>
+      </p:pic>
+      <p:sp>
+        <p:nvSpPr>
+          <p:cNvPr id="1" name="TextBox 3"/>
+          <p:cNvSpPr txBox="1"/>
+          <p:nvPr>
+            <p:ph idx="1"/>
+          </p:nvPr>
+        </p:nvSpPr>
+        <p:spPr>
+          <a:xfrm>
+            <a:off x="457200" y="4076700"/>
+            <a:ext cx="8229600" cy="508000"/>
+          </a:xfrm>
+          <a:prstGeom prst="rect">
+            <a:avLst/>
+          </a:prstGeom>
+          <a:noFill/>
+        </p:spPr>
+        <p:txBody>
+          <a:bodyPr/>
+          <a:lstStyle/>
+          <a:p>
+            <a:pPr lvl="0" indent="0" marL="0" algn="ctr">
+              <a:buNone/>
+            </a:pPr>
+            <a:r>
+              <a:rPr/>
+              <a:t>&lt;piechart
+data='[
+  { "label": "Apples", "value": 10 },
+  { "label": "Bananas", "value": 20 },
+  { "label": "Cherries", "value": 15 },
+  { "label": "Grapes", "value": 25 }
+]'
+  width=500
+  height=500
+  colors='pastel'
+  donut = true
+&gt;</a:t>
+            </a:r>
+          </a:p>
+        </p:txBody>
+      </p:sp>
+    </p:spTree>
+  </p:cSld>
+</p:sld>
+</file>
+
+<file path=ppt/slides/slide28.xml><?xml version="1.0" encoding="utf-8"?>
+<p:sld xmlns:a="http://schemas.openxmlformats.org/drawingml/2006/main" xmlns:r="http://schemas.openxmlformats.org/officeDocument/2006/relationships" xmlns:p="http://schemas.openxmlformats.org/presentationml/2006/main">
+  <p:cSld>
+    <p:spTree>
+      <p:nvGrpSpPr>
+        <p:cNvPr id="1" name=""/>
+        <p:cNvGrpSpPr/>
+        <p:nvPr/>
+      </p:nvGrpSpPr>
+      <p:grpSpPr>
+        <a:xfrm>
+          <a:off x="0" y="0"/>
+          <a:ext cx="0" cy="0"/>
+          <a:chOff x="0" y="0"/>
+          <a:chExt cx="0" cy="0"/>
+        </a:xfrm>
+      </p:grpSpPr>
+      <p:sp>
+        <p:nvSpPr>
+          <p:cNvPr id="2" name="Title 1"/>
+          <p:cNvSpPr>
+            <a:spLocks noGrp="1"/>
+          </p:cNvSpPr>
+          <p:nvPr>
+            <p:ph type="title"/>
+          </p:nvPr>
+        </p:nvSpPr>
+        <p:spPr/>
+        <p:txBody>
+          <a:bodyPr/>
+          <a:lstStyle/>
+          <a:p>
+            <a:pPr lvl="0" indent="0" marL="0">
+              <a:buNone/>
+            </a:pPr>
+            <a:r>
+              <a:rPr/>
+              <a:t>A vertical tree chart</a:t>
+            </a:r>
+          </a:p>
+        </p:txBody>
+      </p:sp>
+      <p:pic>
+        <p:nvPicPr>
+          <p:cNvPr descr="/var/folders/bp/w4c2kztn5fg7yk8vg8k_2wgc0000gn/T/doodlngwzbyw2/svg/tree_0.png" id="0" name="Picture 1"/>
+          <p:cNvPicPr>
+            <a:picLocks noGrp="1" noChangeAspect="1"/>
+          </p:cNvPicPr>
+          <p:nvPr/>
+        </p:nvPicPr>
+        <p:blipFill>
+          <a:blip r:embed="rId2"/>
+          <a:stretch>
+            <a:fillRect/>
+          </a:stretch>
+        </p:blipFill>
+        <p:spPr bwMode="auto">
+          <a:xfrm>
+            <a:off x="1790700" y="1193800"/>
+            <a:ext cx="5549900" cy="2882900"/>
+          </a:xfrm>
+          <a:prstGeom prst="rect">
+            <a:avLst/>
+          </a:prstGeom>
+          <a:noFill/>
+          <a:ln w="9525">
+            <a:noFill/>
+            <a:headEnd/>
+            <a:tailEnd/>
+          </a:ln>
+        </p:spPr>
+      </p:pic>
+      <p:sp>
+        <p:nvSpPr>
+          <p:cNvPr id="1" name="TextBox 3"/>
+          <p:cNvSpPr txBox="1"/>
+          <p:nvPr>
+            <p:ph idx="1"/>
+          </p:nvPr>
+        </p:nvSpPr>
+        <p:spPr>
+          <a:xfrm>
+            <a:off x="457200" y="4076700"/>
+            <a:ext cx="8229600" cy="508000"/>
+          </a:xfrm>
+          <a:prstGeom prst="rect">
+            <a:avLst/>
+          </a:prstGeom>
+          <a:noFill/>
+        </p:spPr>
+        <p:txBody>
+          <a:bodyPr/>
+          <a:lstStyle/>
+          <a:p>
+            <a:pPr lvl="0" indent="0" marL="0" algn="ctr">
+              <a:buNone/>
+            </a:pPr>
+            <a:r>
+              <a:rPr/>
+              <a:t>&lt;tree
+    data='{
+    "name": "root",
+    "children": [
+            { "name": "A", "value": 10 },
+            { "name": "B", "value": 20 },
+            { "name": "C", "children": [
+                { "name": "C1", "value": 10 },
+                { "name": "C2", "value": 5 },
+                { "name": "C3", "value": 15 }
+            ]},
+            { "name": "D", "value": 40 }
+        ]
+    }
+    '
+    width=1000
+  height=500
+    colors='deep'
+    vertical=True&gt;</a:t>
+            </a:r>
+          </a:p>
+        </p:txBody>
+      </p:sp>
+    </p:spTree>
+  </p:cSld>
+</p:sld>
+</file>
+
+<file path=ppt/slides/slide29.xml><?xml version="1.0" encoding="utf-8"?>
+<p:sld xmlns:a="http://schemas.openxmlformats.org/drawingml/2006/main" xmlns:r="http://schemas.openxmlformats.org/officeDocument/2006/relationships" xmlns:p="http://schemas.openxmlformats.org/presentationml/2006/main">
+  <p:cSld>
+    <p:spTree>
+      <p:nvGrpSpPr>
+        <p:cNvPr id="1" name=""/>
+        <p:cNvGrpSpPr/>
+        <p:nvPr/>
+      </p:nvGrpSpPr>
+      <p:grpSpPr>
+        <a:xfrm>
+          <a:off x="0" y="0"/>
+          <a:ext cx="0" cy="0"/>
+          <a:chOff x="0" y="0"/>
+          <a:chExt cx="0" cy="0"/>
+        </a:xfrm>
+      </p:grpSpPr>
+      <p:sp>
+        <p:nvSpPr>
+          <p:cNvPr id="2" name="Title 1"/>
+          <p:cNvSpPr>
+            <a:spLocks noGrp="1"/>
+          </p:cNvSpPr>
+          <p:nvPr>
+            <p:ph type="title"/>
+          </p:nvPr>
+        </p:nvSpPr>
+        <p:spPr/>
+        <p:txBody>
+          <a:bodyPr/>
+          <a:lstStyle/>
+          <a:p>
+            <a:pPr lvl="0" indent="0" marL="0">
+              <a:buNone/>
+            </a:pPr>
+            <a:r>
+              <a:rPr/>
+              <a:t>A gantt chart</a:t>
+            </a:r>
+          </a:p>
+        </p:txBody>
+      </p:sp>
+      <p:pic>
+        <p:nvPicPr>
+          <p:cNvPr descr="/var/folders/bp/w4c2kztn5fg7yk8vg8k_2wgc0000gn/T/doodlngwzbyw2/svg/gantt_0.png" id="0" name="Picture 1"/>
+          <p:cNvPicPr>
+            <a:picLocks noGrp="1" noChangeAspect="1"/>
+          </p:cNvPicPr>
+          <p:nvPr/>
+        </p:nvPicPr>
+        <p:blipFill>
+          <a:blip r:embed="rId2"/>
+          <a:stretch>
+            <a:fillRect/>
+          </a:stretch>
+        </p:blipFill>
+        <p:spPr bwMode="auto">
+          <a:xfrm>
+            <a:off x="1689100" y="1193800"/>
+            <a:ext cx="5765800" cy="2882900"/>
+          </a:xfrm>
+          <a:prstGeom prst="rect">
+            <a:avLst/>
+          </a:prstGeom>
+          <a:noFill/>
+          <a:ln w="9525">
+            <a:noFill/>
+            <a:headEnd/>
+            <a:tailEnd/>
+          </a:ln>
+        </p:spPr>
+      </p:pic>
+      <p:sp>
+        <p:nvSpPr>
+          <p:cNvPr id="1" name="TextBox 3"/>
+          <p:cNvSpPr txBox="1"/>
+          <p:nvPr>
+            <p:ph idx="1"/>
+          </p:nvPr>
+        </p:nvSpPr>
+        <p:spPr>
+          <a:xfrm>
+            <a:off x="457200" y="4076700"/>
+            <a:ext cx="8229600" cy="508000"/>
+          </a:xfrm>
+          <a:prstGeom prst="rect">
+            <a:avLst/>
+          </a:prstGeom>
+          <a:noFill/>
+        </p:spPr>
+        <p:txBody>
+          <a:bodyPr/>
+          <a:lstStyle/>
+          <a:p>
+            <a:pPr lvl="0" indent="0" marL="0" algn="ctr">
+              <a:buNone/>
+            </a:pPr>
+            <a:r>
+              <a:rPr/>
+              <a:t>&lt;gantt
+  data='[
+    { "task": "Planning", "start": "2024-03-01", "end": "2024-03-05" },
+    { "task": "Design", "start": "2024-03-06", "end": "2024-03-12" },
+    { "task": "Development", "start": "2024-03-13", "end": "2024-03-25" },
+    { "task": "Testing", "start": "2024-03-26", "end": "2024-03-30" },
+    { "task": "Deployment", "start": "2024-03-31", "end": "2024-04-02" }
+  ]'
+  width=1000
+  height=500
+  colors='deep'
 &gt;</a:t>
             </a:r>
           </a:p>
@@ -3705,9 +5678,34 @@
           <a:chExt cx="0" cy="0"/>
         </a:xfrm>
       </p:grpSpPr>
+      <p:sp>
+        <p:nvSpPr>
+          <p:cNvPr id="2" name="Title 1"/>
+          <p:cNvSpPr>
+            <a:spLocks noGrp="1"/>
+          </p:cNvSpPr>
+          <p:nvPr>
+            <p:ph type="title"/>
+          </p:nvPr>
+        </p:nvSpPr>
+        <p:spPr/>
+        <p:txBody>
+          <a:bodyPr/>
+          <a:lstStyle/>
+          <a:p>
+            <a:pPr lvl="0" indent="0" marL="0">
+              <a:buNone/>
+            </a:pPr>
+            <a:r>
+              <a:rPr/>
+              <a:t>A multi_linechart</a:t>
+            </a:r>
+          </a:p>
+        </p:txBody>
+      </p:sp>
       <p:pic>
         <p:nvPicPr>
-          <p:cNvPr descr="/var/folders/bp/w4c2kztn5fg7yk8vg8k_2wgc0000gn/T/doodlcat3f6my/svg/areachart_0.png" id="0" name="Picture 1"/>
+          <p:cNvPr descr="/var/folders/bp/w4c2kztn5fg7yk8vg8k_2wgc0000gn/T/doodlngwzbyw2/svg/multi_linechart_0.png" id="0" name="Picture 1"/>
           <p:cNvPicPr>
             <a:picLocks noGrp="1" noChangeAspect="1"/>
           </p:cNvPicPr>
@@ -3762,19 +5760,273 @@
             </a:pPr>
             <a:r>
               <a:rPr/>
-              <a:t>&lt;areachart
+              <a:t>&lt;multi_linechart
 data='[
-  { "date": "2024-01-01", "catA": 10, "catB": 20, "catC": 30 },
-  { "date": "2024-01-02", "catA": 15, "catB": 25, "catC": 35 },
-  { "date": "2024-01-03", "catA": 20, "catB": 22, "catC": 28 },
-  { "date": "2024-01-04", "catA": 18, "catB": 30, "catC": 25 },
-  { "date": "2024-01-05", "catA": 22, "catB": 28, "catC": 32 },
-  { "date": "2024-01-06", "catA": 19, "catB": 26, "catC": 29 },
-  { "date": "2024-01-07", "catA": 24, "catB": 30, "catC": 35 },
-  { "date": "2024-01-08", "catA": 28, "catB": 33, "catC": 40 }
+  { "label": "A", "x": 1, "y": 10 },
+  { "label": "A", "x": 2, "y": 14 },
+  { "label": "A", "x": 3, "y": 18 },
+  { "label": "A", "x": 4, "y": 22 },
+  { "label": "A", "x": 5, "y": 28 },
+  { "label": "A", "x": 6, "y": 32 },
+  { "label": "A", "x": 7, "y": 35 },
+  { "label": "A", "x": 8, "y": 38 },
+  { "label": "A", "x": 9, "y": 40 },
+  { "label": "A", "x": 10, "y": 43 },
+  { "label": "A", "x": 11, "y": 45 },
+  { "label": "A", "x": 12, "y": 48 },
+  { "label": "B", "x": 1, "y": 8 },
+  { "label": "B", "x": 2, "y": 12 },
+  { "label": "B", "x": 3, "y": 16 },
+  { "label": "B", "x": 4, "y": 20 },
+  { "label": "B", "x": 5, "y": 25 },
+  { "label": "B", "x": 6, "y": 30 },
+  { "label": "B", "x": 7, "y": 34 },
+  { "label": "B", "x": 8, "y": 37 },
+  { "label": "B", "x": 9, "y": 39 },
+  { "label": "B", "x": 10, "y": 42 },
+  { "label": "B", "x": 11, "y": 44 },
+  { "label": "B", "x": 12, "y": 47 },
+  { "label": "C", "x": 1, "y": 5 },
+  { "label": "C", "x": 2, "y": 9 },
+  { "label": "C", "x": 3, "y": 12 },
+  { "label": "C", "x": 4, "y": 16 },
+  { "label": "C", "x": 5, "y": 20 },
+  { "label": "C", "x": 6, "y": 23 },
+  { "label": "C", "x": 7, "y": 26 },
+  { "label": "C", "x": 8, "y": 28 },
+  { "label": "C", "x": 9, "y": 30 },
+  { "label": "C", "x": 10, "y": 33 },
+  { "label": "C", "x": 11, "y": 35 },
+  { "label": "C", "x": 12, "y": 37 },
+  { "label": "D", "x": 1, "y": 15 },
+  { "label": "D", "x": 2, "y": 18 },
+  { "label": "D", "x": 3, "y": 20 },
+  { "label": "D", "x": 4, "y": 24 },
+  { "label": "D", "x": 5, "y": 27 },
+  { "label": "D", "x": 6, "y": 29 },
+  { "label": "D", "x": 7, "y": 33 },
+  { "label": "D", "x": 8, "y": 36 },
+  { "label": "D", "x": 9, "y": 38 },
+  { "label": "D", "x": 10, "y": 41 },
+  { "label": "D", "x": 11, "y": 43 },
+  { "label": "D", "x": 12, "y": 46 }
 ]'
-  size='{"width":500,"height":500}'
-  colors='flare'
+  width=500
+  height=500
+  colors='deep'
+  curved='true'
+  show_legend='true'
+&gt;</a:t>
+            </a:r>
+          </a:p>
+        </p:txBody>
+      </p:sp>
+    </p:spTree>
+  </p:cSld>
+</p:sld>
+</file>
+
+<file path=ppt/slides/slide30.xml><?xml version="1.0" encoding="utf-8"?>
+<p:sld xmlns:a="http://schemas.openxmlformats.org/drawingml/2006/main" xmlns:r="http://schemas.openxmlformats.org/officeDocument/2006/relationships" xmlns:p="http://schemas.openxmlformats.org/presentationml/2006/main">
+  <p:cSld>
+    <p:spTree>
+      <p:nvGrpSpPr>
+        <p:cNvPr id="1" name=""/>
+        <p:cNvGrpSpPr/>
+        <p:nvPr/>
+      </p:nvGrpSpPr>
+      <p:grpSpPr>
+        <a:xfrm>
+          <a:off x="0" y="0"/>
+          <a:ext cx="0" cy="0"/>
+          <a:chOff x="0" y="0"/>
+          <a:chExt cx="0" cy="0"/>
+        </a:xfrm>
+      </p:grpSpPr>
+      <p:sp>
+        <p:nvSpPr>
+          <p:cNvPr id="2" name="Title 1"/>
+          <p:cNvSpPr>
+            <a:spLocks noGrp="1"/>
+          </p:cNvSpPr>
+          <p:nvPr>
+            <p:ph type="title"/>
+          </p:nvPr>
+        </p:nvSpPr>
+        <p:spPr/>
+        <p:txBody>
+          <a:bodyPr/>
+          <a:lstStyle/>
+          <a:p>
+            <a:pPr lvl="0" indent="0" marL="0">
+              <a:buNone/>
+            </a:pPr>
+            <a:r>
+              <a:rPr/>
+              <a:t>A chord diagram</a:t>
+            </a:r>
+          </a:p>
+        </p:txBody>
+      </p:sp>
+      <p:pic>
+        <p:nvPicPr>
+          <p:cNvPr descr="/var/folders/bp/w4c2kztn5fg7yk8vg8k_2wgc0000gn/T/doodlngwzbyw2/svg/chord_0.png" id="0" name="Picture 1"/>
+          <p:cNvPicPr>
+            <a:picLocks noGrp="1" noChangeAspect="1"/>
+          </p:cNvPicPr>
+          <p:nvPr/>
+        </p:nvPicPr>
+        <p:blipFill>
+          <a:blip r:embed="rId2"/>
+          <a:stretch>
+            <a:fillRect/>
+          </a:stretch>
+        </p:blipFill>
+        <p:spPr bwMode="auto">
+          <a:xfrm>
+            <a:off x="3124200" y="1193800"/>
+            <a:ext cx="2882900" cy="2882900"/>
+          </a:xfrm>
+          <a:prstGeom prst="rect">
+            <a:avLst/>
+          </a:prstGeom>
+          <a:noFill/>
+          <a:ln w="9525">
+            <a:noFill/>
+            <a:headEnd/>
+            <a:tailEnd/>
+          </a:ln>
+        </p:spPr>
+      </p:pic>
+      <p:sp>
+        <p:nvSpPr>
+          <p:cNvPr id="1" name="TextBox 3"/>
+          <p:cNvSpPr txBox="1"/>
+          <p:nvPr>
+            <p:ph idx="1"/>
+          </p:nvPr>
+        </p:nvSpPr>
+        <p:spPr>
+          <a:xfrm>
+            <a:off x="457200" y="4076700"/>
+            <a:ext cx="8229600" cy="508000"/>
+          </a:xfrm>
+          <a:prstGeom prst="rect">
+            <a:avLst/>
+          </a:prstGeom>
+          <a:noFill/>
+        </p:spPr>
+        <p:txBody>
+          <a:bodyPr/>
+          <a:lstStyle/>
+          <a:p>
+            <a:pPr lvl="0" indent="0" marL="0" algn="ctr">
+              <a:buNone/>
+            </a:pPr>
+            <a:r>
+              <a:rPr/>
+              <a:t>&lt;chord
+data='[
+  [0, 5, 10, 2],
+  [5, 0, 3, 7],
+  [10, 3, 0, 6],
+  [2, 7, 6, 0]
+]
+'
+  width=500
+  height=500
+  colors='deep'
+&gt;</a:t>
+            </a:r>
+          </a:p>
+        </p:txBody>
+      </p:sp>
+    </p:spTree>
+  </p:cSld>
+</p:sld>
+</file>
+
+<file path=ppt/slides/slide31.xml><?xml version="1.0" encoding="utf-8"?>
+<p:sld xmlns:a="http://schemas.openxmlformats.org/drawingml/2006/main" xmlns:r="http://schemas.openxmlformats.org/officeDocument/2006/relationships" xmlns:p="http://schemas.openxmlformats.org/presentationml/2006/main">
+  <p:cSld>
+    <p:spTree>
+      <p:nvGrpSpPr>
+        <p:cNvPr id="1" name=""/>
+        <p:cNvGrpSpPr/>
+        <p:nvPr/>
+      </p:nvGrpSpPr>
+      <p:grpSpPr>
+        <a:xfrm>
+          <a:off x="0" y="0"/>
+          <a:ext cx="0" cy="0"/>
+          <a:chOff x="0" y="0"/>
+          <a:chExt cx="0" cy="0"/>
+        </a:xfrm>
+      </p:grpSpPr>
+      <p:pic>
+        <p:nvPicPr>
+          <p:cNvPr descr="/var/folders/bp/w4c2kztn5fg7yk8vg8k_2wgc0000gn/T/doodlngwzbyw2/svg/bubblechart_0.png" id="0" name="Picture 1"/>
+          <p:cNvPicPr>
+            <a:picLocks noGrp="1" noChangeAspect="1"/>
+          </p:cNvPicPr>
+          <p:nvPr/>
+        </p:nvPicPr>
+        <p:blipFill>
+          <a:blip r:embed="rId2"/>
+          <a:stretch>
+            <a:fillRect/>
+          </a:stretch>
+        </p:blipFill>
+        <p:spPr bwMode="auto">
+          <a:xfrm>
+            <a:off x="3124200" y="1193800"/>
+            <a:ext cx="2882900" cy="2882900"/>
+          </a:xfrm>
+          <a:prstGeom prst="rect">
+            <a:avLst/>
+          </a:prstGeom>
+          <a:noFill/>
+          <a:ln w="9525">
+            <a:noFill/>
+            <a:headEnd/>
+            <a:tailEnd/>
+          </a:ln>
+        </p:spPr>
+      </p:pic>
+      <p:sp>
+        <p:nvSpPr>
+          <p:cNvPr id="1" name="TextBox 3"/>
+          <p:cNvSpPr txBox="1"/>
+          <p:nvPr>
+            <p:ph idx="1"/>
+          </p:nvPr>
+        </p:nvSpPr>
+        <p:spPr>
+          <a:xfrm>
+            <a:off x="457200" y="4076700"/>
+            <a:ext cx="8229600" cy="508000"/>
+          </a:xfrm>
+          <a:prstGeom prst="rect">
+            <a:avLst/>
+          </a:prstGeom>
+          <a:noFill/>
+        </p:spPr>
+        <p:txBody>
+          <a:bodyPr/>
+          <a:lstStyle/>
+          <a:p>
+            <a:pPr lvl="0" indent="0" marL="0" algn="ctr">
+              <a:buNone/>
+            </a:pPr>
+            <a:r>
+              <a:rPr/>
+              <a:t>&lt;bubblechart
+  path="data/flare.json"
+  width=900
+  height=900
+  colors='deep'
+  ease_in=1
+  drag_animations=1
 &gt;</a:t>
             </a:r>
           </a:p>
@@ -3802,9 +6054,34 @@
           <a:chExt cx="0" cy="0"/>
         </a:xfrm>
       </p:grpSpPr>
+      <p:sp>
+        <p:nvSpPr>
+          <p:cNvPr id="2" name="Title 1"/>
+          <p:cNvSpPr>
+            <a:spLocks noGrp="1"/>
+          </p:cNvSpPr>
+          <p:nvPr>
+            <p:ph type="title"/>
+          </p:nvPr>
+        </p:nvSpPr>
+        <p:spPr/>
+        <p:txBody>
+          <a:bodyPr/>
+          <a:lstStyle/>
+          <a:p>
+            <a:pPr lvl="0" indent="0" marL="0">
+              <a:buNone/>
+            </a:pPr>
+            <a:r>
+              <a:rPr/>
+              <a:t>A HORIZONTAL grouped_barchart</a:t>
+            </a:r>
+          </a:p>
+        </p:txBody>
+      </p:sp>
       <p:pic>
         <p:nvPicPr>
-          <p:cNvPr descr="/var/folders/bp/w4c2kztn5fg7yk8vg8k_2wgc0000gn/T/doodlcat3f6my/svg/skey_0.png" id="0" name="Picture 1"/>
+          <p:cNvPr descr="/var/folders/bp/w4c2kztn5fg7yk8vg8k_2wgc0000gn/T/doodlngwzbyw2/svg/grouped_barchart_0.png" id="0" name="Picture 1"/>
           <p:cNvPicPr>
             <a:picLocks noGrp="1" noChangeAspect="1"/>
           </p:cNvPicPr>
@@ -3818,8 +6095,8 @@
         </p:blipFill>
         <p:spPr bwMode="auto">
           <a:xfrm>
-            <a:off x="1689100" y="1193800"/>
-            <a:ext cx="5765800" cy="2882900"/>
+            <a:off x="2844800" y="1193800"/>
+            <a:ext cx="3454400" cy="2882900"/>
           </a:xfrm>
           <a:prstGeom prst="rect">
             <a:avLst/>
@@ -3859,14 +6136,32 @@
             </a:pPr>
             <a:r>
               <a:rPr/>
-              <a:t>&lt;skey
-  file='{
-        "path": "std_focus.json",
-        "format": "json"
-    }'
-    link_color='"target"'
-    colors='cc.glasbey'
-    size='{"width":1000,"height":500}'&gt;</a:t>
+              <a:t>&lt;grouped_barchart
+  data='[
+  { "group": "North", "label": "Q1", "value": 22 },
+  { "group": "North", "label": "Q2", "value": 35 },
+  { "group": "North", "label": "Q3", "value": 40 },
+  { "group": "North", "label": "Q4", "value": 28 },
+  { "group": "South", "label": "Q1", "value": 18 },
+  { "group": "South", "label": "Q2", "value": 30 },
+  { "group": "South", "label": "Q3", "value": 26 },
+  { "group": "South", "label": "Q4", "value": 32 },
+  { "group": "East", "label": "Q1", "value": 25 },
+  { "group": "East", "label": "Q2", "value": 28 },
+  { "group": "East", "label": "Q3", "value": 33 },
+  { "group": "East", "label": "Q4", "value": 29 },
+  { "group": "West", "label": "Q1", "value": 20 },
+  { "group": "West", "label": "Q2", "value": 24 },
+  { "group": "West", "label": "Q3", "value": 32 },
+  { "group": "West", "label": "Q4", "value": 27 }
+]'
+  width=1200
+  height=1000
+  colors='deep'
+  x_label_angle=90
+  show_legend='true'
+  horizontal='true'
+&gt;</a:t>
             </a:r>
           </a:p>
         </p:txBody>
@@ -3893,9 +6188,34 @@
           <a:chExt cx="0" cy="0"/>
         </a:xfrm>
       </p:grpSpPr>
+      <p:sp>
+        <p:nvSpPr>
+          <p:cNvPr id="2" name="Title 1"/>
+          <p:cNvSpPr>
+            <a:spLocks noGrp="1"/>
+          </p:cNvSpPr>
+          <p:nvPr>
+            <p:ph type="title"/>
+          </p:nvPr>
+        </p:nvSpPr>
+        <p:spPr/>
+        <p:txBody>
+          <a:bodyPr/>
+          <a:lstStyle/>
+          <a:p>
+            <a:pPr lvl="0" indent="0" marL="0">
+              <a:buNone/>
+            </a:pPr>
+            <a:r>
+              <a:rPr/>
+              <a:t>A VERTICAL grouped_barchart</a:t>
+            </a:r>
+          </a:p>
+        </p:txBody>
+      </p:sp>
       <p:pic>
         <p:nvPicPr>
-          <p:cNvPr descr="/var/folders/bp/w4c2kztn5fg7yk8vg8k_2wgc0000gn/T/doodlcat3f6my/svg/skey_1.png" id="0" name="Picture 1"/>
+          <p:cNvPr descr="/var/folders/bp/w4c2kztn5fg7yk8vg8k_2wgc0000gn/T/doodlngwzbyw2/svg/grouped_barchart_1.png" id="0" name="Picture 1"/>
           <p:cNvPicPr>
             <a:picLocks noGrp="1" noChangeAspect="1"/>
           </p:cNvPicPr>
@@ -3909,8 +6229,8 @@
         </p:blipFill>
         <p:spPr bwMode="auto">
           <a:xfrm>
-            <a:off x="723900" y="1193800"/>
-            <a:ext cx="7683500" cy="2882900"/>
+            <a:off x="2844800" y="1193800"/>
+            <a:ext cx="3454400" cy="2882900"/>
           </a:xfrm>
           <a:prstGeom prst="rect">
             <a:avLst/>
@@ -3950,13 +6270,30 @@
             </a:pPr>
             <a:r>
               <a:rPr/>
-              <a:t>&lt;skey
-  size='{"width":600,"height":225}'
-  file='{"path": "data/energy.json", "format": "json"}'
-  n_colors=10
-  colors='pastel'
-  link_color='"source-target"'
-  node_align='"right"'
+              <a:t>&lt;grouped_barchart
+  data='[
+  { "group": "North", "label": "Q1", "value": 22 },
+  { "group": "North", "label": "Q2", "value": 35 },
+  { "group": "North", "label": "Q3", "value": 40 },
+  { "group": "North", "label": "Q4", "value": 28 },
+  { "group": "South", "label": "Q1", "value": 18 },
+  { "group": "South", "label": "Q2", "value": 30 },
+  { "group": "South", "label": "Q3", "value": 26 },
+  { "group": "South", "label": "Q4", "value": 32 },
+  { "group": "East", "label": "Q1", "value": 25 },
+  { "group": "East", "label": "Q2", "value": 28 },
+  { "group": "East", "label": "Q3", "value": 33 },
+  { "group": "East", "label": "Q4", "value": 29 },
+  { "group": "West", "label": "Q1", "value": 20 },
+  { "group": "West", "label": "Q2", "value": 24 },
+  { "group": "West", "label": "Q3", "value": 32 },
+  { "group": "West", "label": "Q4", "value": 27 }
+]'
+  width=1200
+  height=1000
+  colors='deep'
+  x_label_angle=90
+  show_legend='true'
 &gt;</a:t>
             </a:r>
           </a:p>
@@ -4004,14 +6341,14 @@
             </a:pPr>
             <a:r>
               <a:rPr/>
-              <a:t>A Pie chart from data file format</a:t>
+              <a:t>A Pie Grid from data file format</a:t>
             </a:r>
           </a:p>
         </p:txBody>
       </p:sp>
       <p:pic>
         <p:nvPicPr>
-          <p:cNvPr descr="/var/folders/bp/w4c2kztn5fg7yk8vg8k_2wgc0000gn/T/doodlcat3f6my/svg/piechart_0.png" id="0" name="Picture 1"/>
+          <p:cNvPr descr="/var/folders/bp/w4c2kztn5fg7yk8vg8k_2wgc0000gn/T/doodlngwzbyw2/svg/piegrid_0.png" id="0" name="Picture 1"/>
           <p:cNvPicPr>
             <a:picLocks noGrp="1" noChangeAspect="1"/>
           </p:cNvPicPr>
@@ -4025,8 +6362,8 @@
         </p:blipFill>
         <p:spPr bwMode="auto">
           <a:xfrm>
-            <a:off x="3124200" y="1193800"/>
-            <a:ext cx="2882900" cy="2882900"/>
+            <a:off x="457200" y="1270000"/>
+            <a:ext cx="8229600" cy="2743200"/>
           </a:xfrm>
           <a:prstGeom prst="rect">
             <a:avLst/>
@@ -4066,11 +6403,15 @@
             </a:pPr>
             <a:r>
               <a:rPr/>
-              <a:t>&lt;piechart
-  file='{"path":"data/pie.json","format":"json"}'
+              <a:t>&lt;piegrid
+  path="data/pie.json"
   width=900
-  height=900
+  height=300
   colors='deep'
+  show_percentages='true'
+  columns=4
+  bg_arc_color='#aaa'
+  text_color='#0000aa'
 &gt;</a:t>
             </a:r>
           </a:p>
@@ -4118,14 +6459,14 @@
             </a:pPr>
             <a:r>
               <a:rPr/>
-              <a:t>A Pie chart from data path format</a:t>
+              <a:t>A HORIZONTAL stacked barchart</a:t>
             </a:r>
           </a:p>
         </p:txBody>
       </p:sp>
       <p:pic>
         <p:nvPicPr>
-          <p:cNvPr descr="/var/folders/bp/w4c2kztn5fg7yk8vg8k_2wgc0000gn/T/doodlcat3f6my/svg/piechart_1.png" id="0" name="Picture 1"/>
+          <p:cNvPr descr="/var/folders/bp/w4c2kztn5fg7yk8vg8k_2wgc0000gn/T/doodlngwzbyw2/svg/stacked_barchart_0.png" id="0" name="Picture 1"/>
           <p:cNvPicPr>
             <a:picLocks noGrp="1" noChangeAspect="1"/>
           </p:cNvPicPr>
@@ -4139,8 +6480,8 @@
         </p:blipFill>
         <p:spPr bwMode="auto">
           <a:xfrm>
-            <a:off x="3124200" y="1193800"/>
-            <a:ext cx="2882900" cy="2882900"/>
+            <a:off x="2844800" y="1193800"/>
+            <a:ext cx="3454400" cy="2882900"/>
           </a:xfrm>
           <a:prstGeom prst="rect">
             <a:avLst/>
@@ -4180,11 +6521,14 @@
             </a:pPr>
             <a:r>
               <a:rPr/>
-              <a:t>&lt;piechart
-  file='{"path":"data/pie.json","format":"json"}'
-  width="900"
-  height="900"
+              <a:t>&lt;stacked_barchart
+  path="data/label_category_value.json"
+  width=1200
+  height=1000
   colors='deep'
+  x_label_angle=90
+  show_legend='true'
+  horizontal='true'
 &gt;</a:t>
             </a:r>
           </a:p>
@@ -4232,14 +6576,14 @@
             </a:pPr>
             <a:r>
               <a:rPr/>
-              <a:t>A Pie chart from data path with format</a:t>
+              <a:t>A VERTICAL stacked barchart</a:t>
             </a:r>
           </a:p>
         </p:txBody>
       </p:sp>
       <p:pic>
         <p:nvPicPr>
-          <p:cNvPr descr="/var/folders/bp/w4c2kztn5fg7yk8vg8k_2wgc0000gn/T/doodlcat3f6my/svg/piechart_2.png" id="0" name="Picture 1"/>
+          <p:cNvPr descr="/var/folders/bp/w4c2kztn5fg7yk8vg8k_2wgc0000gn/T/doodlngwzbyw2/svg/stacked_barchart_1.png" id="0" name="Picture 1"/>
           <p:cNvPicPr>
             <a:picLocks noGrp="1" noChangeAspect="1"/>
           </p:cNvPicPr>
@@ -4253,8 +6597,8 @@
         </p:blipFill>
         <p:spPr bwMode="auto">
           <a:xfrm>
-            <a:off x="3124200" y="1193800"/>
-            <a:ext cx="2882900" cy="2882900"/>
+            <a:off x="2844800" y="1193800"/>
+            <a:ext cx="3454400" cy="2882900"/>
           </a:xfrm>
           <a:prstGeom prst="rect">
             <a:avLst/>
@@ -4294,11 +6638,13 @@
             </a:pPr>
             <a:r>
               <a:rPr/>
-              <a:t>&lt;piechart
-  path="data/pie.json"
-  format="json"
-  size='{"width":500,"height":500}'
+              <a:t>&lt;stacked_barchart
+  path="data/label_category_value.json"
+  width=1200
+  height=1000
   colors='deep'
+  x_label_angle=90
+  show_legend='true'
 &gt;</a:t>
             </a:r>
           </a:p>
@@ -4346,14 +6692,14 @@
             </a:pPr>
             <a:r>
               <a:rPr/>
-              <a:t>A Donut chart</a:t>
+              <a:t>A HORIZONTAL stacked areachart</a:t>
             </a:r>
           </a:p>
         </p:txBody>
       </p:sp>
       <p:pic>
         <p:nvPicPr>
-          <p:cNvPr descr="/var/folders/bp/w4c2kztn5fg7yk8vg8k_2wgc0000gn/T/doodlcat3f6my/svg/piechart_3.png" id="0" name="Picture 1"/>
+          <p:cNvPr descr="/var/folders/bp/w4c2kztn5fg7yk8vg8k_2wgc0000gn/T/doodlngwzbyw2/svg/stacked_areachart_0.png" id="0" name="Picture 1"/>
           <p:cNvPicPr>
             <a:picLocks noGrp="1" noChangeAspect="1"/>
           </p:cNvPicPr>
@@ -4367,8 +6713,8 @@
         </p:blipFill>
         <p:spPr bwMode="auto">
           <a:xfrm>
-            <a:off x="3124200" y="1193800"/>
-            <a:ext cx="2882900" cy="2882900"/>
+            <a:off x="2844800" y="1193800"/>
+            <a:ext cx="3454400" cy="2882900"/>
           </a:xfrm>
           <a:prstGeom prst="rect">
             <a:avLst/>
@@ -4408,16 +6754,14 @@
             </a:pPr>
             <a:r>
               <a:rPr/>
-              <a:t>&lt;piechart
-data='[
-  { "label": "Apples", "value": 10 },
-  { "label": "Bananas", "value": 20 },
-  { "label": "Cherries", "value": 15 },
-  { "label": "Grapes", "value": 25 }
-]'
-  size='{"width":500,"height":500}'
-  colors='pastel'
-  donut = true
+              <a:t>&lt;stacked_areachart
+  path= "data/label_category_value.json"
+  width=1200
+  height=1000
+  colors='deep'
+  x_label_angle=90
+  show_legend='true'
+  horizontal='true'
 &gt;</a:t>
             </a:r>
           </a:p>

</xml_diff>